<commit_message>
docs(apresentacao): usa os números da Gupy conferidos na fonte primária
O deck citava mais de 10 mil empresas clientes, número de material de blog. A página do Google for Startups, que é a fonte primária do caso, diz 2.300 clientes em 2021, 480 mil vagas preenchidas e redução de até 80% no tempo de contratação. Os números da Unilever passam a ser apresentados como o que são: reportados em compilações de estudos de caso, sem publicação primária que eu tenha conseguido conferir.
</commit_message>
<xml_diff>
--- a/apresentacao/radar-de-estagio-pit.pptx
+++ b/apresentacao/radar-de-estagio-pit.pptx
@@ -8188,7 +8188,7 @@
                           <a:ea typeface="Calibri" pitchFamily="34" charset="-122"/>
                           <a:cs typeface="Calibri" pitchFamily="34" charset="-120"/>
                         </a:rPr>
-                        <a:t>NLP na ordenação de candidatos, em mais de 10 mil empresas</a:t>
+                        <a:t>NLP na ordenação e recomendação, em 2.300 empresas clientes (2021)</a:t>
                       </a:r>
                       <a:endParaRPr lang="en-US" sz="950" dirty="0">
                         <a:latin typeface="Calibri" charset="0"/>
@@ -8256,7 +8256,7 @@
                           <a:ea typeface="Calibri" pitchFamily="34" charset="-122"/>
                           <a:cs typeface="Calibri" pitchFamily="34" charset="-120"/>
                         </a:rPr>
-                        <a:t>QuintoAndar: −50% no processo e −35% na triagem. Ambev: 1 em cada 4 entrevistados contratado</a:t>
+                        <a:t>480 mil vagas preenchidas em 2021 e até −80% no tempo de contratação, com 22,5 milhões de candidatos na base</a:t>
                       </a:r>
                       <a:endParaRPr lang="en-US" sz="950" dirty="0">
                         <a:latin typeface="Calibri" charset="0"/>

</xml_diff>

<commit_message>
docs(apresentacao): espelha no pptx a reorganização e os cortes
Mesma escala de texto, mesmo corpo logo abaixo do título e as mesmas mudanças
de capa, demonstração e roteiro. O endereço do site vai como link no slide 5.
</commit_message>
<xml_diff>
--- a/apresentacao/radar-de-estagio-pit.pptx
+++ b/apresentacao/radar-de-estagio-pit.pptx
@@ -511,7 +511,7 @@
           <a:p>
             <a:r>
               <a:rPr lang="en-US" dirty="0"/>
-              <a:t>Somos três alunos e o Radar está no ar há 31 dias, entregando sozinho todo dia às 07:23. Tudo que vem a seguir são números de produção, não de simulação.</a:t>
+              <a:t>Somos três alunos e o Radar já está em produção, entregando sozinho todo dia às 07:23. Tudo que vem a seguir são números de produção, não de simulação.</a:t>
             </a:r>
             <a:endParaRPr lang="en-US" dirty="0"/>
           </a:p>
@@ -775,7 +775,7 @@
           <a:p>
             <a:r>
               <a:rPr lang="en-US" dirty="0"/>
-              <a:t>O público é o estudante de qualquer curso, não só de computação: o catálogo tem 12 áreas e 105 cursos. No piloto são 6 perfis criados e 4 recebendo recomendações.</a:t>
+              <a:t>O público é o estudante de qualquer curso, não só de computação: o catálogo tem 12 áreas e 105 cursos.</a:t>
             </a:r>
             <a:endParaRPr lang="en-US" dirty="0"/>
           </a:p>
@@ -951,7 +951,7 @@
           <a:p>
             <a:r>
               <a:rPr lang="en-US" dirty="0"/>
-              <a:t>À esquerda, o cadastro: o perfil vem antes da conta, de propósito, para não cobrar e-mail e senha antes de mostrar o produto. À direita, a mensagem real das 07:23, com a nota, o que o perfil atende, o que falta conferir e a atribuição obrigatória da Adzuna.</a:t>
+              <a:t>À esquerda, o formulário: o perfil vem antes da conta, de propósito, para não cobrar e-mail e senha antes de mostrar o produto. À direita, a mensagem real das 07:23, com a nota, o que o perfil atende, o que falta conferir e a atribuição obrigatória da Adzuna.</a:t>
             </a:r>
             <a:endParaRPr lang="en-US" dirty="0"/>
           </a:p>
@@ -1723,7 +1723,7 @@
         </p:nvSpPr>
         <p:spPr>
           <a:xfrm>
-            <a:off x="548640" y="1078992"/>
+            <a:off x="548640" y="1417320"/>
             <a:ext cx="8046720" cy="914400"/>
           </a:xfrm>
           <a:prstGeom prst="rect">
@@ -1762,7 +1762,7 @@
         </p:nvSpPr>
         <p:spPr>
           <a:xfrm>
-            <a:off x="548640" y="2084832"/>
+            <a:off x="548640" y="2432304"/>
             <a:ext cx="8046720" cy="566928"/>
           </a:xfrm>
           <a:prstGeom prst="rect">
@@ -1782,7 +1782,7 @@
               <a:buNone/>
             </a:pPr>
             <a:r>
-              <a:rPr lang="en-US" sz="1350" dirty="0">
+              <a:rPr lang="en-US" sz="1400" dirty="0">
                 <a:solidFill>
                   <a:srgbClr val="C2CFC7"/>
                 </a:solidFill>
@@ -1792,135 +1792,36 @@
               </a:rPr>
               <a:t>Um agente que busca vagas de estágio todos os dias, compara cada anúncio com o perfil do estudante e entrega no Telegram até sete recomendações explicadas.</a:t>
             </a:r>
-            <a:endParaRPr lang="en-US" sz="1350" dirty="0"/>
-          </a:p>
-        </p:txBody>
-      </p:sp>
-      <p:sp>
-        <p:nvSpPr>
-          <p:cNvPr id="5" name="Shape 3"/>
-          <p:cNvSpPr/>
-          <p:nvPr/>
-        </p:nvSpPr>
-        <p:spPr>
-          <a:xfrm>
-            <a:off x="548640" y="2999232"/>
-            <a:ext cx="8046720" cy="896112"/>
-          </a:xfrm>
-          <a:prstGeom prst="roundRect">
-            <a:avLst>
-              <a:gd name="adj" fmla="val 6122"/>
-            </a:avLst>
-          </a:prstGeom>
-          <a:solidFill>
-            <a:srgbClr val="17201A"/>
-          </a:solidFill>
-          <a:ln w="12700">
-            <a:solidFill>
-              <a:srgbClr val="26332C"/>
-            </a:solidFill>
-            <a:prstDash val="solid"/>
-          </a:ln>
-        </p:spPr>
-      </p:sp>
-      <p:sp>
-        <p:nvSpPr>
-          <p:cNvPr id="6" name="Shape 4"/>
-          <p:cNvSpPr/>
-          <p:nvPr/>
-        </p:nvSpPr>
-        <p:spPr>
-          <a:xfrm>
-            <a:off x="2560320" y="2999232"/>
-            <a:ext cx="0" cy="896112"/>
-          </a:xfrm>
-          <a:prstGeom prst="line">
-            <a:avLst/>
-          </a:prstGeom>
-          <a:noFill/>
-          <a:ln w="12700">
-            <a:solidFill>
-              <a:srgbClr val="26332C"/>
-            </a:solidFill>
-            <a:prstDash val="solid"/>
-          </a:ln>
-        </p:spPr>
-      </p:sp>
-      <p:sp>
-        <p:nvSpPr>
-          <p:cNvPr id="7" name="Shape 5"/>
-          <p:cNvSpPr/>
-          <p:nvPr/>
-        </p:nvSpPr>
-        <p:spPr>
-          <a:xfrm>
-            <a:off x="4572000" y="2999232"/>
-            <a:ext cx="0" cy="896112"/>
-          </a:xfrm>
-          <a:prstGeom prst="line">
-            <a:avLst/>
-          </a:prstGeom>
-          <a:noFill/>
-          <a:ln w="12700">
-            <a:solidFill>
-              <a:srgbClr val="26332C"/>
-            </a:solidFill>
-            <a:prstDash val="solid"/>
-          </a:ln>
-        </p:spPr>
-      </p:sp>
-      <p:sp>
-        <p:nvSpPr>
-          <p:cNvPr id="8" name="Shape 6"/>
-          <p:cNvSpPr/>
-          <p:nvPr/>
-        </p:nvSpPr>
-        <p:spPr>
-          <a:xfrm>
-            <a:off x="6583680" y="2999232"/>
-            <a:ext cx="0" cy="896112"/>
-          </a:xfrm>
-          <a:prstGeom prst="line">
-            <a:avLst/>
-          </a:prstGeom>
-          <a:noFill/>
-          <a:ln w="12700">
-            <a:solidFill>
-              <a:srgbClr val="26332C"/>
-            </a:solidFill>
-            <a:prstDash val="solid"/>
-          </a:ln>
-        </p:spPr>
-      </p:sp>
-      <p:sp>
-        <p:nvSpPr>
-          <p:cNvPr id="9" name="Text 7"/>
-          <p:cNvSpPr txBox="1"/>
-          <p:nvPr/>
-        </p:nvSpPr>
-        <p:spPr>
-          <a:xfrm>
-            <a:off x="731520" y="3163824"/>
-            <a:ext cx="1645920" cy="274320"/>
-          </a:xfrm>
-          <a:prstGeom prst="rect">
-            <a:avLst/>
-          </a:prstGeom>
-          <a:noFill/>
-          <a:ln/>
-        </p:spPr>
-        <p:txBody>
-          <a:bodyPr wrap="square" lIns="0" tIns="0" rIns="0" bIns="0" rtlCol="0" anchor="ctr"/>
-          <a:lstStyle/>
-          <a:p>
-            <a:pPr indent="0" marL="0">
-              <a:lnSpc>
-                <a:spcPct val="95000"/>
-              </a:lnSpc>
-              <a:buNone/>
-            </a:pPr>
-            <a:r>
-              <a:rPr lang="en-US" sz="1400" b="1" dirty="0">
+            <a:endParaRPr lang="en-US" sz="1400" dirty="0"/>
+          </a:p>
+        </p:txBody>
+      </p:sp>
+      <p:sp>
+        <p:nvSpPr>
+          <p:cNvPr id="5" name="Text 3"/>
+          <p:cNvSpPr txBox="1"/>
+          <p:nvPr/>
+        </p:nvSpPr>
+        <p:spPr>
+          <a:xfrm>
+            <a:off x="548640" y="3310128"/>
+            <a:ext cx="8046720" cy="256032"/>
+          </a:xfrm>
+          <a:prstGeom prst="rect">
+            <a:avLst/>
+          </a:prstGeom>
+          <a:noFill/>
+          <a:ln/>
+        </p:spPr>
+        <p:txBody>
+          <a:bodyPr wrap="square" lIns="0" tIns="0" rIns="0" bIns="0" rtlCol="0" anchor="ctr"/>
+          <a:lstStyle/>
+          <a:p>
+            <a:pPr indent="0" marL="0">
+              <a:buNone/>
+            </a:pPr>
+            <a:r>
+              <a:rPr lang="en-US" sz="1300" b="1" dirty="0">
                 <a:solidFill>
                   <a:srgbClr val="EEF3EF"/>
                 </a:solidFill>
@@ -1928,41 +1829,38 @@
                 <a:ea typeface="Calibri" pitchFamily="34" charset="-122"/>
                 <a:cs typeface="Calibri" pitchFamily="34" charset="-120"/>
               </a:rPr>
-              <a:t>Igor Costa</a:t>
-            </a:r>
-            <a:endParaRPr lang="en-US" sz="1400" dirty="0"/>
-          </a:p>
-        </p:txBody>
-      </p:sp>
-      <p:sp>
-        <p:nvSpPr>
-          <p:cNvPr id="10" name="Text 8"/>
-          <p:cNvSpPr txBox="1"/>
-          <p:nvPr/>
-        </p:nvSpPr>
-        <p:spPr>
-          <a:xfrm>
-            <a:off x="731520" y="3456432"/>
-            <a:ext cx="1645920" cy="329184"/>
-          </a:xfrm>
-          <a:prstGeom prst="rect">
-            <a:avLst/>
-          </a:prstGeom>
-          <a:noFill/>
-          <a:ln/>
-        </p:spPr>
-        <p:txBody>
-          <a:bodyPr wrap="square" lIns="0" tIns="0" rIns="0" bIns="0" rtlCol="0" anchor="ctr"/>
-          <a:lstStyle/>
-          <a:p>
-            <a:pPr indent="0" marL="0">
-              <a:lnSpc>
-                <a:spcPct val="108000"/>
-              </a:lnSpc>
-              <a:buNone/>
-            </a:pPr>
-            <a:r>
-              <a:rPr lang="en-US" sz="1000" dirty="0">
+              <a:t>Igor Costa · Ian Dias · Miguel Esteves</a:t>
+            </a:r>
+            <a:endParaRPr lang="en-US" sz="1300" dirty="0"/>
+          </a:p>
+        </p:txBody>
+      </p:sp>
+      <p:sp>
+        <p:nvSpPr>
+          <p:cNvPr id="6" name="Text 4"/>
+          <p:cNvSpPr txBox="1"/>
+          <p:nvPr/>
+        </p:nvSpPr>
+        <p:spPr>
+          <a:xfrm>
+            <a:off x="548640" y="3602736"/>
+            <a:ext cx="8046720" cy="256032"/>
+          </a:xfrm>
+          <a:prstGeom prst="rect">
+            <a:avLst/>
+          </a:prstGeom>
+          <a:noFill/>
+          <a:ln/>
+        </p:spPr>
+        <p:txBody>
+          <a:bodyPr wrap="square" lIns="0" tIns="0" rIns="0" bIns="0" rtlCol="0" anchor="ctr"/>
+          <a:lstStyle/>
+          <a:p>
+            <a:pPr indent="0" marL="0">
+              <a:buNone/>
+            </a:pPr>
+            <a:r>
+              <a:rPr lang="en-US" sz="1200" dirty="0">
                 <a:solidFill>
                   <a:srgbClr val="C2CFC7"/>
                 </a:solidFill>
@@ -1970,300 +1868,9 @@
                 <a:ea typeface="Calibri" pitchFamily="34" charset="-122"/>
                 <a:cs typeface="Calibri" pitchFamily="34" charset="-120"/>
               </a:rPr>
-              <a:t>pipeline, matching e banco</a:t>
-            </a:r>
-            <a:endParaRPr lang="en-US" sz="1000" dirty="0"/>
-          </a:p>
-        </p:txBody>
-      </p:sp>
-      <p:sp>
-        <p:nvSpPr>
-          <p:cNvPr id="11" name="Text 9"/>
-          <p:cNvSpPr txBox="1"/>
-          <p:nvPr/>
-        </p:nvSpPr>
-        <p:spPr>
-          <a:xfrm>
-            <a:off x="2743200" y="3163824"/>
-            <a:ext cx="1645920" cy="274320"/>
-          </a:xfrm>
-          <a:prstGeom prst="rect">
-            <a:avLst/>
-          </a:prstGeom>
-          <a:noFill/>
-          <a:ln/>
-        </p:spPr>
-        <p:txBody>
-          <a:bodyPr wrap="square" lIns="0" tIns="0" rIns="0" bIns="0" rtlCol="0" anchor="ctr"/>
-          <a:lstStyle/>
-          <a:p>
-            <a:pPr indent="0" marL="0">
-              <a:lnSpc>
-                <a:spcPct val="95000"/>
-              </a:lnSpc>
-              <a:buNone/>
-            </a:pPr>
-            <a:r>
-              <a:rPr lang="en-US" sz="1400" b="1" dirty="0">
-                <a:solidFill>
-                  <a:srgbClr val="EEF3EF"/>
-                </a:solidFill>
-                <a:latin typeface="Calibri" pitchFamily="34" charset="0"/>
-                <a:ea typeface="Calibri" pitchFamily="34" charset="-122"/>
-                <a:cs typeface="Calibri" pitchFamily="34" charset="-120"/>
-              </a:rPr>
-              <a:t>Ian Dias</a:t>
-            </a:r>
-            <a:endParaRPr lang="en-US" sz="1400" dirty="0"/>
-          </a:p>
-        </p:txBody>
-      </p:sp>
-      <p:sp>
-        <p:nvSpPr>
-          <p:cNvPr id="12" name="Text 10"/>
-          <p:cNvSpPr txBox="1"/>
-          <p:nvPr/>
-        </p:nvSpPr>
-        <p:spPr>
-          <a:xfrm>
-            <a:off x="2743200" y="3456432"/>
-            <a:ext cx="1645920" cy="329184"/>
-          </a:xfrm>
-          <a:prstGeom prst="rect">
-            <a:avLst/>
-          </a:prstGeom>
-          <a:noFill/>
-          <a:ln/>
-        </p:spPr>
-        <p:txBody>
-          <a:bodyPr wrap="square" lIns="0" tIns="0" rIns="0" bIns="0" rtlCol="0" anchor="ctr"/>
-          <a:lstStyle/>
-          <a:p>
-            <a:pPr indent="0" marL="0">
-              <a:lnSpc>
-                <a:spcPct val="108000"/>
-              </a:lnSpc>
-              <a:buNone/>
-            </a:pPr>
-            <a:r>
-              <a:rPr lang="en-US" sz="1000" dirty="0">
-                <a:solidFill>
-                  <a:srgbClr val="C2CFC7"/>
-                </a:solidFill>
-                <a:latin typeface="Calibri" pitchFamily="34" charset="0"/>
-                <a:ea typeface="Calibri" pitchFamily="34" charset="-122"/>
-                <a:cs typeface="Calibri" pitchFamily="34" charset="-120"/>
-              </a:rPr>
-              <a:t>operação, coleta e entrega</a:t>
-            </a:r>
-            <a:endParaRPr lang="en-US" sz="1000" dirty="0"/>
-          </a:p>
-        </p:txBody>
-      </p:sp>
-      <p:sp>
-        <p:nvSpPr>
-          <p:cNvPr id="13" name="Text 11"/>
-          <p:cNvSpPr txBox="1"/>
-          <p:nvPr/>
-        </p:nvSpPr>
-        <p:spPr>
-          <a:xfrm>
-            <a:off x="4754880" y="3163824"/>
-            <a:ext cx="1645920" cy="274320"/>
-          </a:xfrm>
-          <a:prstGeom prst="rect">
-            <a:avLst/>
-          </a:prstGeom>
-          <a:noFill/>
-          <a:ln/>
-        </p:spPr>
-        <p:txBody>
-          <a:bodyPr wrap="square" lIns="0" tIns="0" rIns="0" bIns="0" rtlCol="0" anchor="ctr"/>
-          <a:lstStyle/>
-          <a:p>
-            <a:pPr indent="0" marL="0">
-              <a:lnSpc>
-                <a:spcPct val="95000"/>
-              </a:lnSpc>
-              <a:buNone/>
-            </a:pPr>
-            <a:r>
-              <a:rPr lang="en-US" sz="1400" b="1" dirty="0">
-                <a:solidFill>
-                  <a:srgbClr val="EEF3EF"/>
-                </a:solidFill>
-                <a:latin typeface="Calibri" pitchFamily="34" charset="0"/>
-                <a:ea typeface="Calibri" pitchFamily="34" charset="-122"/>
-                <a:cs typeface="Calibri" pitchFamily="34" charset="-120"/>
-              </a:rPr>
-              <a:t>Miguel Esteves</a:t>
-            </a:r>
-            <a:endParaRPr lang="en-US" sz="1400" dirty="0"/>
-          </a:p>
-        </p:txBody>
-      </p:sp>
-      <p:sp>
-        <p:nvSpPr>
-          <p:cNvPr id="14" name="Text 12"/>
-          <p:cNvSpPr txBox="1"/>
-          <p:nvPr/>
-        </p:nvSpPr>
-        <p:spPr>
-          <a:xfrm>
-            <a:off x="4754880" y="3456432"/>
-            <a:ext cx="1645920" cy="329184"/>
-          </a:xfrm>
-          <a:prstGeom prst="rect">
-            <a:avLst/>
-          </a:prstGeom>
-          <a:noFill/>
-          <a:ln/>
-        </p:spPr>
-        <p:txBody>
-          <a:bodyPr wrap="square" lIns="0" tIns="0" rIns="0" bIns="0" rtlCol="0" anchor="ctr"/>
-          <a:lstStyle/>
-          <a:p>
-            <a:pPr indent="0" marL="0">
-              <a:lnSpc>
-                <a:spcPct val="108000"/>
-              </a:lnSpc>
-              <a:buNone/>
-            </a:pPr>
-            <a:r>
-              <a:rPr lang="en-US" sz="1000" dirty="0">
-                <a:solidFill>
-                  <a:srgbClr val="C2CFC7"/>
-                </a:solidFill>
-                <a:latin typeface="Calibri" pitchFamily="34" charset="0"/>
-                <a:ea typeface="Calibri" pitchFamily="34" charset="-122"/>
-                <a:cs typeface="Calibri" pitchFamily="34" charset="-120"/>
-              </a:rPr>
-              <a:t>cadastro, dados e privacidade</a:t>
-            </a:r>
-            <a:endParaRPr lang="en-US" sz="1000" dirty="0"/>
-          </a:p>
-        </p:txBody>
-      </p:sp>
-      <p:sp>
-        <p:nvSpPr>
-          <p:cNvPr id="15" name="Text 13"/>
-          <p:cNvSpPr txBox="1"/>
-          <p:nvPr/>
-        </p:nvSpPr>
-        <p:spPr>
-          <a:xfrm>
-            <a:off x="6766560" y="3163824"/>
-            <a:ext cx="1645920" cy="274320"/>
-          </a:xfrm>
-          <a:prstGeom prst="rect">
-            <a:avLst/>
-          </a:prstGeom>
-          <a:noFill/>
-          <a:ln/>
-        </p:spPr>
-        <p:txBody>
-          <a:bodyPr wrap="square" lIns="0" tIns="0" rIns="0" bIns="0" rtlCol="0" anchor="ctr"/>
-          <a:lstStyle/>
-          <a:p>
-            <a:pPr indent="0" marL="0">
-              <a:lnSpc>
-                <a:spcPct val="95000"/>
-              </a:lnSpc>
-              <a:buNone/>
-            </a:pPr>
-            <a:r>
-              <a:rPr lang="en-US" sz="1400" b="1" dirty="0">
-                <a:solidFill>
-                  <a:srgbClr val="9FD3B2"/>
-                </a:solidFill>
-                <a:latin typeface="Calibri" pitchFamily="34" charset="0"/>
-                <a:ea typeface="Calibri" pitchFamily="34" charset="-122"/>
-                <a:cs typeface="Calibri" pitchFamily="34" charset="-120"/>
-              </a:rPr>
-              <a:t>31 dias no ar</a:t>
-            </a:r>
-            <a:endParaRPr lang="en-US" sz="1400" dirty="0"/>
-          </a:p>
-        </p:txBody>
-      </p:sp>
-      <p:sp>
-        <p:nvSpPr>
-          <p:cNvPr id="16" name="Text 14"/>
-          <p:cNvSpPr txBox="1"/>
-          <p:nvPr/>
-        </p:nvSpPr>
-        <p:spPr>
-          <a:xfrm>
-            <a:off x="6766560" y="3456432"/>
-            <a:ext cx="1645920" cy="329184"/>
-          </a:xfrm>
-          <a:prstGeom prst="rect">
-            <a:avLst/>
-          </a:prstGeom>
-          <a:noFill/>
-          <a:ln/>
-        </p:spPr>
-        <p:txBody>
-          <a:bodyPr wrap="square" lIns="0" tIns="0" rIns="0" bIns="0" rtlCol="0" anchor="ctr"/>
-          <a:lstStyle/>
-          <a:p>
-            <a:pPr indent="0" marL="0">
-              <a:lnSpc>
-                <a:spcPct val="108000"/>
-              </a:lnSpc>
-              <a:buNone/>
-            </a:pPr>
-            <a:r>
-              <a:rPr lang="en-US" sz="1000" dirty="0">
-                <a:solidFill>
-                  <a:srgbClr val="C2CFC7"/>
-                </a:solidFill>
-                <a:latin typeface="Calibri" pitchFamily="34" charset="0"/>
-                <a:ea typeface="Calibri" pitchFamily="34" charset="-122"/>
-                <a:cs typeface="Calibri" pitchFamily="34" charset="-120"/>
-              </a:rPr>
-              <a:t>410 recomendações entregues</a:t>
-            </a:r>
-            <a:endParaRPr lang="en-US" sz="1000" dirty="0"/>
-          </a:p>
-        </p:txBody>
-      </p:sp>
-      <p:sp>
-        <p:nvSpPr>
-          <p:cNvPr id="17" name="Text 15"/>
-          <p:cNvSpPr txBox="1"/>
-          <p:nvPr/>
-        </p:nvSpPr>
-        <p:spPr>
-          <a:xfrm>
-            <a:off x="548640" y="4133088"/>
-            <a:ext cx="8046720" cy="219456"/>
-          </a:xfrm>
-          <a:prstGeom prst="rect">
-            <a:avLst/>
-          </a:prstGeom>
-          <a:noFill/>
-          <a:ln/>
-        </p:spPr>
-        <p:txBody>
-          <a:bodyPr wrap="square" lIns="0" tIns="0" rIns="0" bIns="0" rtlCol="0" anchor="ctr"/>
-          <a:lstStyle/>
-          <a:p>
-            <a:pPr indent="0" marL="0">
-              <a:buNone/>
-            </a:pPr>
-            <a:r>
-              <a:rPr lang="en-US" sz="800" dirty="0">
-                <a:solidFill>
-                  <a:srgbClr val="8FA298"/>
-                </a:solidFill>
-                <a:latin typeface="Courier New" pitchFamily="34" charset="0"/>
-                <a:ea typeface="Courier New" pitchFamily="34" charset="-122"/>
-                <a:cs typeface="Courier New" pitchFamily="34" charset="-120"/>
-              </a:rPr>
               <a:t>Métodos e Aplicações de IA · IBM3116</a:t>
             </a:r>
-            <a:endParaRPr lang="en-US" sz="800" dirty="0"/>
+            <a:endParaRPr lang="en-US" sz="1200" dirty="0"/>
           </a:p>
         </p:txBody>
       </p:sp>
@@ -2388,12 +1995,12 @@
         </p:nvSpPr>
         <p:spPr>
           <a:xfrm>
-            <a:off x="548640" y="1517904"/>
-            <a:ext cx="8046720" cy="1481328"/>
+            <a:off x="548640" y="1280160"/>
+            <a:ext cx="8046720" cy="1783080"/>
           </a:xfrm>
           <a:prstGeom prst="roundRect">
             <a:avLst>
-              <a:gd name="adj" fmla="val 3704"/>
+              <a:gd name="adj" fmla="val 3077"/>
             </a:avLst>
           </a:prstGeom>
           <a:solidFill>
@@ -2415,8 +2022,8 @@
         </p:nvSpPr>
         <p:spPr>
           <a:xfrm>
-            <a:off x="2560320" y="1517904"/>
-            <a:ext cx="0" cy="1481328"/>
+            <a:off x="2560320" y="1280160"/>
+            <a:ext cx="0" cy="1783080"/>
           </a:xfrm>
           <a:prstGeom prst="line">
             <a:avLst/>
@@ -2438,8 +2045,8 @@
         </p:nvSpPr>
         <p:spPr>
           <a:xfrm>
-            <a:off x="4572000" y="1517904"/>
-            <a:ext cx="0" cy="1481328"/>
+            <a:off x="4572000" y="1280160"/>
+            <a:ext cx="0" cy="1783080"/>
           </a:xfrm>
           <a:prstGeom prst="line">
             <a:avLst/>
@@ -2461,8 +2068,8 @@
         </p:nvSpPr>
         <p:spPr>
           <a:xfrm>
-            <a:off x="6583680" y="1517904"/>
-            <a:ext cx="0" cy="1481328"/>
+            <a:off x="6583680" y="1280160"/>
+            <a:ext cx="0" cy="1783080"/>
           </a:xfrm>
           <a:prstGeom prst="line">
             <a:avLst/>
@@ -2484,7 +2091,7 @@
         </p:nvSpPr>
         <p:spPr>
           <a:xfrm>
-            <a:off x="731520" y="1664208"/>
+            <a:off x="731520" y="1426464"/>
             <a:ext cx="1645920" cy="182880"/>
           </a:xfrm>
           <a:prstGeom prst="rect">
@@ -2509,7 +2116,7 @@
                 <a:ea typeface="Courier New" pitchFamily="34" charset="-122"/>
                 <a:cs typeface="Courier New" pitchFamily="34" charset="-120"/>
               </a:rPr>
-              <a:t>AGOSTO</a:t>
+              <a:t>ETAPA 1</a:t>
             </a:r>
             <a:endParaRPr lang="en-US" sz="750" dirty="0"/>
           </a:p>
@@ -2523,7 +2130,7 @@
         </p:nvSpPr>
         <p:spPr>
           <a:xfrm>
-            <a:off x="731520" y="1865376"/>
+            <a:off x="731520" y="1627632"/>
             <a:ext cx="1645920" cy="457200"/>
           </a:xfrm>
           <a:prstGeom prst="rect">
@@ -2565,8 +2172,8 @@
         </p:nvSpPr>
         <p:spPr>
           <a:xfrm>
-            <a:off x="731520" y="2359152"/>
-            <a:ext cx="1645920" cy="530352"/>
+            <a:off x="731520" y="2121408"/>
+            <a:ext cx="1645920" cy="832104"/>
           </a:xfrm>
           <a:prstGeom prst="rect">
             <a:avLst/>
@@ -2585,7 +2192,7 @@
               <a:buNone/>
             </a:pPr>
             <a:r>
-              <a:rPr lang="en-US" sz="1000" dirty="0">
+              <a:rPr lang="en-US" sz="1100" dirty="0">
                 <a:solidFill>
                   <a:srgbClr val="C2CFC7"/>
                 </a:solidFill>
@@ -2595,7 +2202,7 @@
               </a:rPr>
               <a:t>Coleta e nota em Python, com perfil fixo e sem banco.</a:t>
             </a:r>
-            <a:endParaRPr lang="en-US" sz="1000" dirty="0"/>
+            <a:endParaRPr lang="en-US" sz="1100" dirty="0"/>
           </a:p>
         </p:txBody>
       </p:sp>
@@ -2607,7 +2214,7 @@
         </p:nvSpPr>
         <p:spPr>
           <a:xfrm>
-            <a:off x="2743200" y="1664208"/>
+            <a:off x="2743200" y="1426464"/>
             <a:ext cx="1645920" cy="182880"/>
           </a:xfrm>
           <a:prstGeom prst="rect">
@@ -2632,7 +2239,7 @@
                 <a:ea typeface="Courier New" pitchFamily="34" charset="-122"/>
                 <a:cs typeface="Courier New" pitchFamily="34" charset="-120"/>
               </a:rPr>
-              <a:t>28/08</a:t>
+              <a:t>ETAPA 2</a:t>
             </a:r>
             <a:endParaRPr lang="en-US" sz="750" dirty="0"/>
           </a:p>
@@ -2646,7 +2253,7 @@
         </p:nvSpPr>
         <p:spPr>
           <a:xfrm>
-            <a:off x="2743200" y="1865376"/>
+            <a:off x="2743200" y="1627632"/>
             <a:ext cx="1645920" cy="457200"/>
           </a:xfrm>
           <a:prstGeom prst="rect">
@@ -2688,8 +2295,8 @@
         </p:nvSpPr>
         <p:spPr>
           <a:xfrm>
-            <a:off x="2743200" y="2359152"/>
-            <a:ext cx="1645920" cy="530352"/>
+            <a:off x="2743200" y="2121408"/>
+            <a:ext cx="1645920" cy="832104"/>
           </a:xfrm>
           <a:prstGeom prst="rect">
             <a:avLst/>
@@ -2708,7 +2315,7 @@
               <a:buNone/>
             </a:pPr>
             <a:r>
-              <a:rPr lang="en-US" sz="1000" dirty="0">
+              <a:rPr lang="en-US" sz="1100" dirty="0">
                 <a:solidFill>
                   <a:srgbClr val="C2CFC7"/>
                 </a:solidFill>
@@ -2716,46 +2323,21 @@
                 <a:ea typeface="Calibri" pitchFamily="34" charset="-122"/>
                 <a:cs typeface="Calibri" pitchFamily="34" charset="-120"/>
               </a:rPr>
-              <a:t>Banco, conta no site, Telegram e entrega diária automática.</a:t>
-            </a:r>
-            <a:endParaRPr lang="en-US" sz="1000" dirty="0"/>
-          </a:p>
-        </p:txBody>
-      </p:sp>
-      <p:sp>
-        <p:nvSpPr>
-          <p:cNvPr id="14" name="Shape 12"/>
-          <p:cNvSpPr/>
-          <p:nvPr/>
-        </p:nvSpPr>
-        <p:spPr>
-          <a:xfrm>
-            <a:off x="4590288" y="1536192"/>
-            <a:ext cx="1975104" cy="1444752"/>
-          </a:xfrm>
-          <a:prstGeom prst="rect">
-            <a:avLst/>
-          </a:prstGeom>
-          <a:solidFill>
-            <a:srgbClr val="1C2620"/>
-          </a:solidFill>
-          <a:ln w="12700">
-            <a:solidFill>
-              <a:srgbClr val="1C2620"/>
-            </a:solidFill>
-            <a:prstDash val="solid"/>
-          </a:ln>
-        </p:spPr>
-      </p:sp>
-      <p:sp>
-        <p:nvSpPr>
-          <p:cNvPr id="15" name="Text 13"/>
-          <p:cNvSpPr txBox="1"/>
-          <p:nvPr/>
-        </p:nvSpPr>
-        <p:spPr>
-          <a:xfrm>
-            <a:off x="4754880" y="1664208"/>
+              <a:t>Banco, conta no site, vínculo com o Telegram e entrega diária automática.</a:t>
+            </a:r>
+            <a:endParaRPr lang="en-US" sz="1100" dirty="0"/>
+          </a:p>
+        </p:txBody>
+      </p:sp>
+      <p:sp>
+        <p:nvSpPr>
+          <p:cNvPr id="14" name="Text 12"/>
+          <p:cNvSpPr txBox="1"/>
+          <p:nvPr/>
+        </p:nvSpPr>
+        <p:spPr>
+          <a:xfrm>
+            <a:off x="4754880" y="1426464"/>
             <a:ext cx="1645920" cy="182880"/>
           </a:xfrm>
           <a:prstGeom prst="rect">
@@ -2780,7 +2362,7 @@
                 <a:ea typeface="Courier New" pitchFamily="34" charset="-122"/>
                 <a:cs typeface="Courier New" pitchFamily="34" charset="-120"/>
               </a:rPr>
-              <a:t>AGORA</a:t>
+              <a:t>ETAPA 3</a:t>
             </a:r>
             <a:endParaRPr lang="en-US" sz="750" dirty="0"/>
           </a:p>
@@ -2788,13 +2370,13 @@
       </p:sp>
       <p:sp>
         <p:nvSpPr>
-          <p:cNvPr id="16" name="Text 14"/>
-          <p:cNvSpPr txBox="1"/>
-          <p:nvPr/>
-        </p:nvSpPr>
-        <p:spPr>
-          <a:xfrm>
-            <a:off x="4754880" y="1865376"/>
+          <p:cNvPr id="15" name="Text 13"/>
+          <p:cNvSpPr txBox="1"/>
+          <p:nvPr/>
+        </p:nvSpPr>
+        <p:spPr>
+          <a:xfrm>
+            <a:off x="4754880" y="1627632"/>
             <a:ext cx="1645920" cy="457200"/>
           </a:xfrm>
           <a:prstGeom prst="rect">
@@ -2816,7 +2398,7 @@
             <a:r>
               <a:rPr lang="en-US" sz="1400" b="1" dirty="0">
                 <a:solidFill>
-                  <a:srgbClr val="E5B567"/>
+                  <a:srgbClr val="EEF3EF"/>
                 </a:solidFill>
                 <a:latin typeface="Calibri" pitchFamily="34" charset="0"/>
                 <a:ea typeface="Calibri" pitchFamily="34" charset="-122"/>
@@ -2830,14 +2412,14 @@
       </p:sp>
       <p:sp>
         <p:nvSpPr>
-          <p:cNvPr id="17" name="Text 15"/>
-          <p:cNvSpPr txBox="1"/>
-          <p:nvPr/>
-        </p:nvSpPr>
-        <p:spPr>
-          <a:xfrm>
-            <a:off x="4754880" y="2359152"/>
-            <a:ext cx="1645920" cy="530352"/>
+          <p:cNvPr id="16" name="Text 14"/>
+          <p:cNvSpPr txBox="1"/>
+          <p:nvPr/>
+        </p:nvSpPr>
+        <p:spPr>
+          <a:xfrm>
+            <a:off x="4754880" y="2121408"/>
+            <a:ext cx="1645920" cy="832104"/>
           </a:xfrm>
           <a:prstGeom prst="rect">
             <a:avLst/>
@@ -2856,7 +2438,7 @@
               <a:buNone/>
             </a:pPr>
             <a:r>
-              <a:rPr lang="en-US" sz="1000" dirty="0">
+              <a:rPr lang="en-US" sz="1100" dirty="0">
                 <a:solidFill>
                   <a:srgbClr val="C2CFC7"/>
                 </a:solidFill>
@@ -2864,21 +2446,21 @@
                 <a:ea typeface="Calibri" pitchFamily="34" charset="-122"/>
                 <a:cs typeface="Calibri" pitchFamily="34" charset="-120"/>
               </a:rPr>
-              <a:t>6 perfis, 4 ativados, 410 recomendações. Falta o sinal de utilidade.</a:t>
-            </a:r>
-            <a:endParaRPr lang="en-US" sz="1000" dirty="0"/>
-          </a:p>
-        </p:txBody>
-      </p:sp>
-      <p:sp>
-        <p:nvSpPr>
-          <p:cNvPr id="18" name="Text 16"/>
-          <p:cNvSpPr txBox="1"/>
-          <p:nvPr/>
-        </p:nvSpPr>
-        <p:spPr>
-          <a:xfrm>
-            <a:off x="6766560" y="1664208"/>
+              <a:t>Validar com estudantes: o sinal de utilidade é o que permite calibrar a nota.</a:t>
+            </a:r>
+            <a:endParaRPr lang="en-US" sz="1100" dirty="0"/>
+          </a:p>
+        </p:txBody>
+      </p:sp>
+      <p:sp>
+        <p:nvSpPr>
+          <p:cNvPr id="17" name="Text 15"/>
+          <p:cNvSpPr txBox="1"/>
+          <p:nvPr/>
+        </p:nvSpPr>
+        <p:spPr>
+          <a:xfrm>
+            <a:off x="6766560" y="1426464"/>
             <a:ext cx="1645920" cy="182880"/>
           </a:xfrm>
           <a:prstGeom prst="rect">
@@ -2903,7 +2485,7 @@
                 <a:ea typeface="Courier New" pitchFamily="34" charset="-122"/>
                 <a:cs typeface="Courier New" pitchFamily="34" charset="-120"/>
               </a:rPr>
-              <a:t>A SEGUIR</a:t>
+              <a:t>ETAPA 4</a:t>
             </a:r>
             <a:endParaRPr lang="en-US" sz="750" dirty="0"/>
           </a:p>
@@ -2911,13 +2493,13 @@
       </p:sp>
       <p:sp>
         <p:nvSpPr>
-          <p:cNvPr id="19" name="Text 17"/>
-          <p:cNvSpPr txBox="1"/>
-          <p:nvPr/>
-        </p:nvSpPr>
-        <p:spPr>
-          <a:xfrm>
-            <a:off x="6766560" y="1865376"/>
+          <p:cNvPr id="18" name="Text 16"/>
+          <p:cNvSpPr txBox="1"/>
+          <p:nvPr/>
+        </p:nvSpPr>
+        <p:spPr>
+          <a:xfrm>
+            <a:off x="6766560" y="1627632"/>
             <a:ext cx="1645920" cy="457200"/>
           </a:xfrm>
           <a:prstGeom prst="rect">
@@ -2953,14 +2535,14 @@
       </p:sp>
       <p:sp>
         <p:nvSpPr>
-          <p:cNvPr id="20" name="Text 18"/>
-          <p:cNvSpPr txBox="1"/>
-          <p:nvPr/>
-        </p:nvSpPr>
-        <p:spPr>
-          <a:xfrm>
-            <a:off x="6766560" y="2359152"/>
-            <a:ext cx="1645920" cy="530352"/>
+          <p:cNvPr id="19" name="Text 17"/>
+          <p:cNvSpPr txBox="1"/>
+          <p:nvPr/>
+        </p:nvSpPr>
+        <p:spPr>
+          <a:xfrm>
+            <a:off x="6766560" y="2121408"/>
+            <a:ext cx="1645920" cy="832104"/>
           </a:xfrm>
           <a:prstGeom prst="rect">
             <a:avLst/>
@@ -2979,7 +2561,7 @@
               <a:buNone/>
             </a:pPr>
             <a:r>
-              <a:rPr lang="en-US" sz="1000" dirty="0">
+              <a:rPr lang="en-US" sz="1100" dirty="0">
                 <a:solidFill>
                   <a:srgbClr val="C2CFC7"/>
                 </a:solidFill>
@@ -2989,24 +2571,24 @@
               </a:rPr>
               <a:t>Domínio próprio, textos legais aprovados e um pagador definido.</a:t>
             </a:r>
-            <a:endParaRPr lang="en-US" sz="1000" dirty="0"/>
-          </a:p>
-        </p:txBody>
-      </p:sp>
-      <p:sp>
-        <p:nvSpPr>
-          <p:cNvPr id="21" name="Shape 19"/>
+            <a:endParaRPr lang="en-US" sz="1100" dirty="0"/>
+          </a:p>
+        </p:txBody>
+      </p:sp>
+      <p:sp>
+        <p:nvSpPr>
+          <p:cNvPr id="20" name="Shape 18"/>
           <p:cNvSpPr/>
           <p:nvPr/>
         </p:nvSpPr>
         <p:spPr>
           <a:xfrm>
-            <a:off x="548640" y="3236976"/>
-            <a:ext cx="8046720" cy="1207008"/>
+            <a:off x="548640" y="3291840"/>
+            <a:ext cx="8046720" cy="1225296"/>
           </a:xfrm>
           <a:prstGeom prst="roundRect">
             <a:avLst>
-              <a:gd name="adj" fmla="val 4545"/>
+              <a:gd name="adj" fmla="val 4478"/>
             </a:avLst>
           </a:prstGeom>
           <a:solidFill>
@@ -3022,13 +2604,13 @@
       </p:sp>
       <p:sp>
         <p:nvSpPr>
-          <p:cNvPr id="22" name="Text 20"/>
-          <p:cNvSpPr txBox="1"/>
-          <p:nvPr/>
-        </p:nvSpPr>
-        <p:spPr>
-          <a:xfrm>
-            <a:off x="804672" y="3419856"/>
+          <p:cNvPr id="21" name="Text 19"/>
+          <p:cNvSpPr txBox="1"/>
+          <p:nvPr/>
+        </p:nvSpPr>
+        <p:spPr>
+          <a:xfrm>
+            <a:off x="804672" y="3474720"/>
             <a:ext cx="7534656" cy="365760"/>
           </a:xfrm>
           <a:prstGeom prst="rect">
@@ -3061,14 +2643,14 @@
       </p:sp>
       <p:sp>
         <p:nvSpPr>
-          <p:cNvPr id="23" name="Text 21"/>
-          <p:cNvSpPr txBox="1"/>
-          <p:nvPr/>
-        </p:nvSpPr>
-        <p:spPr>
-          <a:xfrm>
-            <a:off x="804672" y="3822192"/>
-            <a:ext cx="7534656" cy="512064"/>
+          <p:cNvPr id="22" name="Text 20"/>
+          <p:cNvSpPr txBox="1"/>
+          <p:nvPr/>
+        </p:nvSpPr>
+        <p:spPr>
+          <a:xfrm>
+            <a:off x="804672" y="3877056"/>
+            <a:ext cx="7534656" cy="530352"/>
           </a:xfrm>
           <a:prstGeom prst="rect">
             <a:avLst/>
@@ -3087,7 +2669,7 @@
               <a:buNone/>
             </a:pPr>
             <a:r>
-              <a:rPr lang="en-US" sz="1100" dirty="0">
+              <a:rPr lang="en-US" sz="1150" dirty="0">
                 <a:solidFill>
                   <a:srgbClr val="C2CFC7"/>
                 </a:solidFill>
@@ -3095,9 +2677,9 @@
                 <a:ea typeface="Calibri" pitchFamily="34" charset="-122"/>
                 <a:cs typeface="Calibri" pitchFamily="34" charset="-120"/>
               </a:rPr>
-              <a:t>Tecnicamente, já roda sozinho há 31 dias. Como produto, ainda falta a prova de que a recomendação serve — e é isso, não mais código, que decide o próximo passo.</a:t>
-            </a:r>
-            <a:endParaRPr lang="en-US" sz="1100" dirty="0"/>
+              <a:t>Tecnicamente o sistema já roda sozinho, todo dia, sem ninguém apertar nada. Como produto, ainda falta a prova de que a recomendação serve — e é isso, não mais código, que decide o próximo passo.</a:t>
+            </a:r>
+            <a:endParaRPr lang="en-US" sz="1150" dirty="0"/>
           </a:p>
         </p:txBody>
       </p:sp>
@@ -3242,12 +2824,12 @@
         </p:nvSpPr>
         <p:spPr>
           <a:xfrm>
-            <a:off x="548640" y="2029968"/>
-            <a:ext cx="8046720" cy="1298448"/>
+            <a:off x="548640" y="1783080"/>
+            <a:ext cx="8046720" cy="1325880"/>
           </a:xfrm>
           <a:prstGeom prst="roundRect">
             <a:avLst>
-              <a:gd name="adj" fmla="val 4225"/>
+              <a:gd name="adj" fmla="val 4138"/>
             </a:avLst>
           </a:prstGeom>
           <a:solidFill>
@@ -3269,8 +2851,8 @@
         </p:nvSpPr>
         <p:spPr>
           <a:xfrm>
-            <a:off x="3230880" y="2029968"/>
-            <a:ext cx="0" cy="1298448"/>
+            <a:off x="3230880" y="1783080"/>
+            <a:ext cx="0" cy="1325880"/>
           </a:xfrm>
           <a:prstGeom prst="line">
             <a:avLst/>
@@ -3292,8 +2874,8 @@
         </p:nvSpPr>
         <p:spPr>
           <a:xfrm>
-            <a:off x="5913120" y="2029968"/>
-            <a:ext cx="0" cy="1298448"/>
+            <a:off x="5913120" y="1783080"/>
+            <a:ext cx="0" cy="1325880"/>
           </a:xfrm>
           <a:prstGeom prst="line">
             <a:avLst/>
@@ -3315,7 +2897,7 @@
         </p:nvSpPr>
         <p:spPr>
           <a:xfrm>
-            <a:off x="731520" y="2194560"/>
+            <a:off x="731520" y="1947672"/>
             <a:ext cx="2316480" cy="512064"/>
           </a:xfrm>
           <a:prstGeom prst="rect">
@@ -3357,8 +2939,8 @@
         </p:nvSpPr>
         <p:spPr>
           <a:xfrm>
-            <a:off x="731520" y="2761488"/>
-            <a:ext cx="2316480" cy="457200"/>
+            <a:off x="731520" y="2514600"/>
+            <a:ext cx="2316480" cy="484632"/>
           </a:xfrm>
           <a:prstGeom prst="rect">
             <a:avLst/>
@@ -3377,7 +2959,7 @@
               <a:buNone/>
             </a:pPr>
             <a:r>
-              <a:rPr lang="en-US" sz="1000" dirty="0">
+              <a:rPr lang="en-US" sz="1100" dirty="0">
                 <a:solidFill>
                   <a:srgbClr val="C2CFC7"/>
                 </a:solidFill>
@@ -3387,7 +2969,7 @@
               </a:rPr>
               <a:t>anúncios coletados na execução de hoje</a:t>
             </a:r>
-            <a:endParaRPr lang="en-US" sz="1000" dirty="0"/>
+            <a:endParaRPr lang="en-US" sz="1100" dirty="0"/>
           </a:p>
         </p:txBody>
       </p:sp>
@@ -3399,7 +2981,7 @@
         </p:nvSpPr>
         <p:spPr>
           <a:xfrm>
-            <a:off x="3413760" y="2194560"/>
+            <a:off x="3413760" y="1947672"/>
             <a:ext cx="2316480" cy="512064"/>
           </a:xfrm>
           <a:prstGeom prst="rect">
@@ -3441,8 +3023,8 @@
         </p:nvSpPr>
         <p:spPr>
           <a:xfrm>
-            <a:off x="3413760" y="2761488"/>
-            <a:ext cx="2316480" cy="457200"/>
+            <a:off x="3413760" y="2514600"/>
+            <a:ext cx="2316480" cy="484632"/>
           </a:xfrm>
           <a:prstGeom prst="rect">
             <a:avLst/>
@@ -3461,7 +3043,7 @@
               <a:buNone/>
             </a:pPr>
             <a:r>
-              <a:rPr lang="en-US" sz="1000" dirty="0">
+              <a:rPr lang="en-US" sz="1100" dirty="0">
                 <a:solidFill>
                   <a:srgbClr val="C2CFC7"/>
                 </a:solidFill>
@@ -3471,7 +3053,7 @@
               </a:rPr>
               <a:t>sobram para um perfil, depois de curso, cidade e modalidade</a:t>
             </a:r>
-            <a:endParaRPr lang="en-US" sz="1000" dirty="0"/>
+            <a:endParaRPr lang="en-US" sz="1100" dirty="0"/>
           </a:p>
         </p:txBody>
       </p:sp>
@@ -3483,7 +3065,7 @@
         </p:nvSpPr>
         <p:spPr>
           <a:xfrm>
-            <a:off x="6096000" y="2194560"/>
+            <a:off x="6096000" y="1947672"/>
             <a:ext cx="2316480" cy="512064"/>
           </a:xfrm>
           <a:prstGeom prst="rect">
@@ -3525,8 +3107,8 @@
         </p:nvSpPr>
         <p:spPr>
           <a:xfrm>
-            <a:off x="6096000" y="2761488"/>
-            <a:ext cx="2316480" cy="457200"/>
+            <a:off x="6096000" y="2514600"/>
+            <a:ext cx="2316480" cy="484632"/>
           </a:xfrm>
           <a:prstGeom prst="rect">
             <a:avLst/>
@@ -3545,7 +3127,7 @@
               <a:buNone/>
             </a:pPr>
             <a:r>
-              <a:rPr lang="en-US" sz="1000" dirty="0">
+              <a:rPr lang="en-US" sz="1100" dirty="0">
                 <a:solidFill>
                   <a:srgbClr val="C2CFC7"/>
                 </a:solidFill>
@@ -3555,7 +3137,7 @@
               </a:rPr>
               <a:t>chegam ao estudante, as únicas acima da nota mínima</a:t>
             </a:r>
-            <a:endParaRPr lang="en-US" sz="1000" dirty="0"/>
+            <a:endParaRPr lang="en-US" sz="1100" dirty="0"/>
           </a:p>
         </p:txBody>
       </p:sp>
@@ -3567,7 +3149,7 @@
         </p:nvSpPr>
         <p:spPr>
           <a:xfrm>
-            <a:off x="548640" y="3611880"/>
+            <a:off x="548640" y="3310128"/>
             <a:ext cx="8046720" cy="566928"/>
           </a:xfrm>
           <a:prstGeom prst="rect">
@@ -3587,7 +3169,7 @@
               <a:buNone/>
             </a:pPr>
             <a:r>
-              <a:rPr lang="en-US" sz="1200" dirty="0">
+              <a:rPr lang="en-US" sz="1300" dirty="0">
                 <a:solidFill>
                   <a:srgbClr val="C2CFC7"/>
                 </a:solidFill>
@@ -3597,7 +3179,7 @@
               </a:rPr>
               <a:t>Esse funil existe com ou sem o Radar. Sem ele, quem descarta é o estudante — todo dia, à mão. No Brasil, 20,1 milhões podem estagiar e 1,2 milhão consegue.</a:t>
             </a:r>
-            <a:endParaRPr lang="en-US" sz="1200" dirty="0"/>
+            <a:endParaRPr lang="en-US" sz="1300" dirty="0"/>
           </a:p>
         </p:txBody>
       </p:sp>
@@ -3609,7 +3191,7 @@
         </p:nvSpPr>
         <p:spPr>
           <a:xfrm>
-            <a:off x="548640" y="4315968"/>
+            <a:off x="548640" y="4023360"/>
             <a:ext cx="8046720" cy="219456"/>
           </a:xfrm>
           <a:prstGeom prst="rect">
@@ -3755,18 +3337,60 @@
       </p:sp>
       <p:sp>
         <p:nvSpPr>
-          <p:cNvPr id="4" name="Shape 2"/>
+          <p:cNvPr id="4" name="Text 2"/>
+          <p:cNvSpPr txBox="1"/>
+          <p:nvPr/>
+        </p:nvSpPr>
+        <p:spPr>
+          <a:xfrm>
+            <a:off x="548640" y="1170432"/>
+            <a:ext cx="8046720" cy="566928"/>
+          </a:xfrm>
+          <a:prstGeom prst="rect">
+            <a:avLst/>
+          </a:prstGeom>
+          <a:noFill/>
+          <a:ln/>
+        </p:spPr>
+        <p:txBody>
+          <a:bodyPr wrap="square" lIns="0" tIns="0" rIns="0" bIns="0" rtlCol="0" anchor="ctr"/>
+          <a:lstStyle/>
+          <a:p>
+            <a:pPr indent="0" marL="0">
+              <a:lnSpc>
+                <a:spcPct val="110000"/>
+              </a:lnSpc>
+              <a:buNone/>
+            </a:pPr>
+            <a:r>
+              <a:rPr lang="en-US" sz="1300" dirty="0">
+                <a:solidFill>
+                  <a:srgbClr val="C2CFC7"/>
+                </a:solidFill>
+                <a:latin typeface="Calibri" pitchFamily="34" charset="0"/>
+                <a:ea typeface="Calibri" pitchFamily="34" charset="-122"/>
+                <a:cs typeface="Calibri" pitchFamily="34" charset="-120"/>
+              </a:rPr>
+              <a:t>O Radar atende quem está procurando o primeiro estágio e não tem tempo de abrir portal todo dia. A busca continua a mesma; o que muda é quem faz a triagem.</a:t>
+            </a:r>
+            <a:endParaRPr lang="en-US" sz="1300" dirty="0"/>
+          </a:p>
+        </p:txBody>
+      </p:sp>
+      <p:sp>
+        <p:nvSpPr>
+          <p:cNvPr id="5" name="Shape 3"/>
           <p:cNvSpPr/>
           <p:nvPr/>
         </p:nvSpPr>
         <p:spPr>
           <a:xfrm>
-            <a:off x="548640" y="1536192"/>
-            <a:ext cx="3931920" cy="2148840"/>
+            <a:off x="548640" y="1847088"/>
+            <a:ext cx="3931920" cy="2194560"/>
           </a:xfrm>
           <a:prstGeom prst="roundRect">
             <a:avLst>
-              <a:gd name="adj" fmla="val 2553"/>
+              <a:gd name="adj" fmla="val 2500"/>
             </a:avLst>
           </a:prstGeom>
           <a:solidFill>
@@ -3782,13 +3406,13 @@
       </p:sp>
       <p:sp>
         <p:nvSpPr>
-          <p:cNvPr id="5" name="Text 3"/>
-          <p:cNvSpPr txBox="1"/>
-          <p:nvPr/>
-        </p:nvSpPr>
-        <p:spPr>
-          <a:xfrm>
-            <a:off x="731520" y="1682496"/>
+          <p:cNvPr id="6" name="Text 4"/>
+          <p:cNvSpPr txBox="1"/>
+          <p:nvPr/>
+        </p:nvSpPr>
+        <p:spPr>
+          <a:xfrm>
+            <a:off x="731520" y="1993392"/>
             <a:ext cx="3566160" cy="384048"/>
           </a:xfrm>
           <a:prstGeom prst="rect">
@@ -3808,7 +3432,7 @@
               <a:buNone/>
             </a:pPr>
             <a:r>
-              <a:rPr lang="en-US" sz="1250" b="1" dirty="0">
+              <a:rPr lang="en-US" sz="1350" b="1" dirty="0">
                 <a:solidFill>
                   <a:srgbClr val="EEF3EF"/>
                 </a:solidFill>
@@ -3818,20 +3442,20 @@
               </a:rPr>
               <a:t>Quem usa</a:t>
             </a:r>
-            <a:endParaRPr lang="en-US" sz="1250" dirty="0"/>
-          </a:p>
-        </p:txBody>
-      </p:sp>
-      <p:sp>
-        <p:nvSpPr>
-          <p:cNvPr id="6" name="Text 4"/>
-          <p:cNvSpPr txBox="1"/>
-          <p:nvPr/>
-        </p:nvSpPr>
-        <p:spPr>
-          <a:xfrm>
-            <a:off x="731520" y="2084832"/>
-            <a:ext cx="3566160" cy="1453896"/>
+            <a:endParaRPr lang="en-US" sz="1350" dirty="0"/>
+          </a:p>
+        </p:txBody>
+      </p:sp>
+      <p:sp>
+        <p:nvSpPr>
+          <p:cNvPr id="7" name="Text 5"/>
+          <p:cNvSpPr txBox="1"/>
+          <p:nvPr/>
+        </p:nvSpPr>
+        <p:spPr>
+          <a:xfrm>
+            <a:off x="731520" y="2395728"/>
+            <a:ext cx="3566160" cy="1499616"/>
           </a:xfrm>
           <a:prstGeom prst="rect">
             <a:avLst/>
@@ -3854,7 +3478,7 @@
               <a:buChar char="•"/>
             </a:pPr>
             <a:r>
-              <a:rPr lang="en-US" sz="1050" dirty="0">
+              <a:rPr lang="en-US" sz="1150" dirty="0">
                 <a:solidFill>
                   <a:srgbClr val="C2CFC7"/>
                 </a:solidFill>
@@ -3864,7 +3488,7 @@
               </a:rPr>
               <a:t>Estudante de graduação, qualquer curso das 12 áreas do catálogo</a:t>
             </a:r>
-            <a:endParaRPr lang="en-US" sz="1050" dirty="0"/>
+            <a:endParaRPr lang="en-US" sz="1150" dirty="0"/>
           </a:p>
           <a:p>
             <a:pPr marL="342900" indent="-342900">
@@ -3878,7 +3502,7 @@
               <a:buChar char="•"/>
             </a:pPr>
             <a:r>
-              <a:rPr lang="en-US" sz="1050" dirty="0">
+              <a:rPr lang="en-US" sz="1150" dirty="0">
                 <a:solidFill>
                   <a:srgbClr val="C2CFC7"/>
                 </a:solidFill>
@@ -3888,7 +3512,7 @@
               </a:rPr>
               <a:t>Procura o primeiro estágio e não tem tempo de triar anúncio todo dia</a:t>
             </a:r>
-            <a:endParaRPr lang="en-US" sz="1050" dirty="0"/>
+            <a:endParaRPr lang="en-US" sz="1150" dirty="0"/>
           </a:p>
           <a:p>
             <a:pPr marL="342900" indent="-342900">
@@ -3902,7 +3526,7 @@
               <a:buChar char="•"/>
             </a:pPr>
             <a:r>
-              <a:rPr lang="en-US" sz="1050" dirty="0">
+              <a:rPr lang="en-US" sz="1150" dirty="0">
                 <a:solidFill>
                   <a:srgbClr val="C2CFC7"/>
                 </a:solidFill>
@@ -3912,24 +3536,24 @@
               </a:rPr>
               <a:t>Já usa Telegram — nenhum aplicativo novo</a:t>
             </a:r>
-            <a:endParaRPr lang="en-US" sz="1050" dirty="0"/>
-          </a:p>
-        </p:txBody>
-      </p:sp>
-      <p:sp>
-        <p:nvSpPr>
-          <p:cNvPr id="7" name="Shape 5"/>
+            <a:endParaRPr lang="en-US" sz="1150" dirty="0"/>
+          </a:p>
+        </p:txBody>
+      </p:sp>
+      <p:sp>
+        <p:nvSpPr>
+          <p:cNvPr id="8" name="Shape 6"/>
           <p:cNvSpPr/>
           <p:nvPr/>
         </p:nvSpPr>
         <p:spPr>
           <a:xfrm>
-            <a:off x="4663440" y="1536192"/>
-            <a:ext cx="3931920" cy="2148840"/>
+            <a:off x="4663440" y="1847088"/>
+            <a:ext cx="3931920" cy="2194560"/>
           </a:xfrm>
           <a:prstGeom prst="roundRect">
             <a:avLst>
-              <a:gd name="adj" fmla="val 2553"/>
+              <a:gd name="adj" fmla="val 2500"/>
             </a:avLst>
           </a:prstGeom>
           <a:solidFill>
@@ -3945,13 +3569,13 @@
       </p:sp>
       <p:sp>
         <p:nvSpPr>
-          <p:cNvPr id="8" name="Text 6"/>
-          <p:cNvSpPr txBox="1"/>
-          <p:nvPr/>
-        </p:nvSpPr>
-        <p:spPr>
-          <a:xfrm>
-            <a:off x="4846320" y="1682496"/>
+          <p:cNvPr id="9" name="Text 7"/>
+          <p:cNvSpPr txBox="1"/>
+          <p:nvPr/>
+        </p:nvSpPr>
+        <p:spPr>
+          <a:xfrm>
+            <a:off x="4846320" y="1993392"/>
             <a:ext cx="3566160" cy="384048"/>
           </a:xfrm>
           <a:prstGeom prst="rect">
@@ -3971,7 +3595,7 @@
               <a:buNone/>
             </a:pPr>
             <a:r>
-              <a:rPr lang="en-US" sz="1250" b="1" dirty="0">
+              <a:rPr lang="en-US" sz="1350" b="1" dirty="0">
                 <a:solidFill>
                   <a:srgbClr val="EEF3EF"/>
                 </a:solidFill>
@@ -3981,20 +3605,20 @@
               </a:rPr>
               <a:t>Como ele faz hoje</a:t>
             </a:r>
-            <a:endParaRPr lang="en-US" sz="1250" dirty="0"/>
-          </a:p>
-        </p:txBody>
-      </p:sp>
-      <p:sp>
-        <p:nvSpPr>
-          <p:cNvPr id="9" name="Text 7"/>
-          <p:cNvSpPr txBox="1"/>
-          <p:nvPr/>
-        </p:nvSpPr>
-        <p:spPr>
-          <a:xfrm>
-            <a:off x="4846320" y="2084832"/>
-            <a:ext cx="3566160" cy="1453896"/>
+            <a:endParaRPr lang="en-US" sz="1350" dirty="0"/>
+          </a:p>
+        </p:txBody>
+      </p:sp>
+      <p:sp>
+        <p:nvSpPr>
+          <p:cNvPr id="10" name="Text 8"/>
+          <p:cNvSpPr txBox="1"/>
+          <p:nvPr/>
+        </p:nvSpPr>
+        <p:spPr>
+          <a:xfrm>
+            <a:off x="4846320" y="2395728"/>
+            <a:ext cx="3566160" cy="1499616"/>
           </a:xfrm>
           <a:prstGeom prst="rect">
             <a:avLst/>
@@ -4017,7 +3641,7 @@
               <a:buChar char="•"/>
             </a:pPr>
             <a:r>
-              <a:rPr lang="en-US" sz="1050" dirty="0">
+              <a:rPr lang="en-US" sz="1150" dirty="0">
                 <a:solidFill>
                   <a:srgbClr val="C2CFC7"/>
                 </a:solidFill>
@@ -4027,7 +3651,7 @@
               </a:rPr>
               <a:t>Abre vários portais e repete a mesma busca</a:t>
             </a:r>
-            <a:endParaRPr lang="en-US" sz="1050" dirty="0"/>
+            <a:endParaRPr lang="en-US" sz="1150" dirty="0"/>
           </a:p>
           <a:p>
             <a:pPr marL="342900" indent="-342900">
@@ -4041,7 +3665,7 @@
               <a:buChar char="•"/>
             </a:pPr>
             <a:r>
-              <a:rPr lang="en-US" sz="1050" dirty="0">
+              <a:rPr lang="en-US" sz="1150" dirty="0">
                 <a:solidFill>
                   <a:srgbClr val="C2CFC7"/>
                 </a:solidFill>
@@ -4051,7 +3675,7 @@
               </a:rPr>
               <a:t>Lê o anúncio inteiro para saber se o curso é aceito</a:t>
             </a:r>
-            <a:endParaRPr lang="en-US" sz="1050" dirty="0"/>
+            <a:endParaRPr lang="en-US" sz="1150" dirty="0"/>
           </a:p>
           <a:p>
             <a:pPr marL="342900" indent="-342900">
@@ -4065,7 +3689,7 @@
               <a:buChar char="•"/>
             </a:pPr>
             <a:r>
-              <a:rPr lang="en-US" sz="1050" dirty="0">
+              <a:rPr lang="en-US" sz="1150" dirty="0">
                 <a:solidFill>
                   <a:srgbClr val="C2CFC7"/>
                 </a:solidFill>
@@ -4075,7 +3699,7 @@
               </a:rPr>
               <a:t>Reencontra a mesma vaga republicada com outro título</a:t>
             </a:r>
-            <a:endParaRPr lang="en-US" sz="1050" dirty="0"/>
+            <a:endParaRPr lang="en-US" sz="1150" dirty="0"/>
           </a:p>
         </p:txBody>
       </p:sp>
@@ -4200,7 +3824,7 @@
         </p:nvSpPr>
         <p:spPr>
           <a:xfrm>
-            <a:off x="548640" y="1371600"/>
+            <a:off x="548640" y="1188720"/>
             <a:ext cx="8046720" cy="566928"/>
           </a:xfrm>
           <a:prstGeom prst="rect">
@@ -4220,7 +3844,7 @@
               <a:buNone/>
             </a:pPr>
             <a:r>
-              <a:rPr lang="en-US" sz="1200" dirty="0">
+              <a:rPr lang="en-US" sz="1300" dirty="0">
                 <a:solidFill>
                   <a:srgbClr val="C2CFC7"/>
                 </a:solidFill>
@@ -4230,7 +3854,7 @@
               </a:rPr>
               <a:t>O estudante preenche o perfil uma vez. Todo dia às 07:23, pelo GitHub Actions, o sistema coleta, descarta o que não serve, pede à IA apenas os fatos do anúncio e calcula a compatibilidade por regras determinísticas.</a:t>
             </a:r>
-            <a:endParaRPr lang="en-US" sz="1200" dirty="0"/>
+            <a:endParaRPr lang="en-US" sz="1300" dirty="0"/>
           </a:p>
         </p:txBody>
       </p:sp>
@@ -4242,8 +3866,8 @@
         </p:nvSpPr>
         <p:spPr>
           <a:xfrm>
-            <a:off x="548640" y="2212848"/>
-            <a:ext cx="1901952" cy="1920240"/>
+            <a:off x="548640" y="1993392"/>
+            <a:ext cx="1901952" cy="2057400"/>
           </a:xfrm>
           <a:prstGeom prst="roundRect">
             <a:avLst>
@@ -4269,7 +3893,7 @@
         </p:nvSpPr>
         <p:spPr>
           <a:xfrm>
-            <a:off x="731520" y="2359152"/>
+            <a:off x="731520" y="2139696"/>
             <a:ext cx="1536192" cy="384048"/>
           </a:xfrm>
           <a:prstGeom prst="rect">
@@ -4289,7 +3913,7 @@
               <a:buNone/>
             </a:pPr>
             <a:r>
-              <a:rPr lang="en-US" sz="1250" b="1" dirty="0">
+              <a:rPr lang="en-US" sz="1350" b="1" dirty="0">
                 <a:solidFill>
                   <a:srgbClr val="EEF3EF"/>
                 </a:solidFill>
@@ -4299,7 +3923,7 @@
               </a:rPr>
               <a:t>Coleta e filtro</a:t>
             </a:r>
-            <a:endParaRPr lang="en-US" sz="1250" dirty="0"/>
+            <a:endParaRPr lang="en-US" sz="1350" dirty="0"/>
           </a:p>
         </p:txBody>
       </p:sp>
@@ -4311,8 +3935,8 @@
         </p:nvSpPr>
         <p:spPr>
           <a:xfrm>
-            <a:off x="731520" y="2761488"/>
-            <a:ext cx="1536192" cy="1225296"/>
+            <a:off x="731520" y="2542032"/>
+            <a:ext cx="1536192" cy="1362456"/>
           </a:xfrm>
           <a:prstGeom prst="rect">
             <a:avLst/>
@@ -4331,7 +3955,7 @@
               <a:buNone/>
             </a:pPr>
             <a:r>
-              <a:rPr lang="en-US" sz="1000" dirty="0">
+              <a:rPr lang="en-US" sz="1150" dirty="0">
                 <a:solidFill>
                   <a:srgbClr val="C2CFC7"/>
                 </a:solidFill>
@@ -4341,7 +3965,7 @@
               </a:rPr>
               <a:t>API da Adzuna, deduplicação e pré-filtro por curso, cidade e modalidade. Sem IA.</a:t>
             </a:r>
-            <a:endParaRPr lang="en-US" sz="1000" dirty="0"/>
+            <a:endParaRPr lang="en-US" sz="1150" dirty="0"/>
           </a:p>
         </p:txBody>
       </p:sp>
@@ -4353,8 +3977,8 @@
         </p:nvSpPr>
         <p:spPr>
           <a:xfrm>
-            <a:off x="2596896" y="2212848"/>
-            <a:ext cx="1901952" cy="1920240"/>
+            <a:off x="2596896" y="1993392"/>
+            <a:ext cx="1901952" cy="2057400"/>
           </a:xfrm>
           <a:prstGeom prst="roundRect">
             <a:avLst>
@@ -4380,7 +4004,7 @@
         </p:nvSpPr>
         <p:spPr>
           <a:xfrm>
-            <a:off x="2779776" y="2359152"/>
+            <a:off x="2779776" y="2139696"/>
             <a:ext cx="1536192" cy="384048"/>
           </a:xfrm>
           <a:prstGeom prst="rect">
@@ -4400,7 +4024,7 @@
               <a:buNone/>
             </a:pPr>
             <a:r>
-              <a:rPr lang="en-US" sz="1250" b="1" dirty="0">
+              <a:rPr lang="en-US" sz="1350" b="1" dirty="0">
                 <a:solidFill>
                   <a:srgbClr val="EEF3EF"/>
                 </a:solidFill>
@@ -4410,7 +4034,7 @@
               </a:rPr>
               <a:t>Extração por IA</a:t>
             </a:r>
-            <a:endParaRPr lang="en-US" sz="1250" dirty="0"/>
+            <a:endParaRPr lang="en-US" sz="1350" dirty="0"/>
           </a:p>
         </p:txBody>
       </p:sp>
@@ -4422,8 +4046,8 @@
         </p:nvSpPr>
         <p:spPr>
           <a:xfrm>
-            <a:off x="2779776" y="2761488"/>
-            <a:ext cx="1536192" cy="1225296"/>
+            <a:off x="2779776" y="2542032"/>
+            <a:ext cx="1536192" cy="1362456"/>
           </a:xfrm>
           <a:prstGeom prst="rect">
             <a:avLst/>
@@ -4442,7 +4066,7 @@
               <a:buNone/>
             </a:pPr>
             <a:r>
-              <a:rPr lang="en-US" sz="1000" dirty="0">
+              <a:rPr lang="en-US" sz="1150" dirty="0">
                 <a:solidFill>
                   <a:srgbClr val="C2CFC7"/>
                 </a:solidFill>
@@ -4452,7 +4076,7 @@
               </a:rPr>
               <a:t>Gemini Flash devolve requisitos, cursos aceitos, período e modalidade em JSON validado.</a:t>
             </a:r>
-            <a:endParaRPr lang="en-US" sz="1000" dirty="0"/>
+            <a:endParaRPr lang="en-US" sz="1150" dirty="0"/>
           </a:p>
         </p:txBody>
       </p:sp>
@@ -4464,8 +4088,8 @@
         </p:nvSpPr>
         <p:spPr>
           <a:xfrm>
-            <a:off x="4645152" y="2212848"/>
-            <a:ext cx="1901952" cy="1920240"/>
+            <a:off x="4645152" y="1993392"/>
+            <a:ext cx="1901952" cy="2057400"/>
           </a:xfrm>
           <a:prstGeom prst="roundRect">
             <a:avLst>
@@ -4491,7 +4115,7 @@
         </p:nvSpPr>
         <p:spPr>
           <a:xfrm>
-            <a:off x="4828032" y="2359152"/>
+            <a:off x="4828032" y="2139696"/>
             <a:ext cx="1536192" cy="384048"/>
           </a:xfrm>
           <a:prstGeom prst="rect">
@@ -4511,7 +4135,7 @@
               <a:buNone/>
             </a:pPr>
             <a:r>
-              <a:rPr lang="en-US" sz="1250" b="1" dirty="0">
+              <a:rPr lang="en-US" sz="1350" b="1" dirty="0">
                 <a:solidFill>
                   <a:srgbClr val="EEF3EF"/>
                 </a:solidFill>
@@ -4521,7 +4145,7 @@
               </a:rPr>
               <a:t>Nota determinística</a:t>
             </a:r>
-            <a:endParaRPr lang="en-US" sz="1250" dirty="0"/>
+            <a:endParaRPr lang="en-US" sz="1350" dirty="0"/>
           </a:p>
         </p:txBody>
       </p:sp>
@@ -4533,8 +4157,8 @@
         </p:nvSpPr>
         <p:spPr>
           <a:xfrm>
-            <a:off x="4828032" y="2761488"/>
-            <a:ext cx="1536192" cy="1225296"/>
+            <a:off x="4828032" y="2542032"/>
+            <a:ext cx="1536192" cy="1362456"/>
           </a:xfrm>
           <a:prstGeom prst="rect">
             <a:avLst/>
@@ -4553,7 +4177,7 @@
               <a:buNone/>
             </a:pPr>
             <a:r>
-              <a:rPr lang="en-US" sz="1000" dirty="0">
+              <a:rPr lang="en-US" sz="1150" dirty="0">
                 <a:solidFill>
                   <a:srgbClr val="C2CFC7"/>
                 </a:solidFill>
@@ -4563,7 +4187,7 @@
               </a:rPr>
               <a:t>Python puro: 45% habilidades, 15% período, 10% curso, 10% área, 10% logística, 10% interesse.</a:t>
             </a:r>
-            <a:endParaRPr lang="en-US" sz="1000" dirty="0"/>
+            <a:endParaRPr lang="en-US" sz="1150" dirty="0"/>
           </a:p>
         </p:txBody>
       </p:sp>
@@ -4575,8 +4199,8 @@
         </p:nvSpPr>
         <p:spPr>
           <a:xfrm>
-            <a:off x="6693408" y="2212848"/>
-            <a:ext cx="1901952" cy="1920240"/>
+            <a:off x="6693408" y="1993392"/>
+            <a:ext cx="1901952" cy="2057400"/>
           </a:xfrm>
           <a:prstGeom prst="roundRect">
             <a:avLst>
@@ -4602,7 +4226,7 @@
         </p:nvSpPr>
         <p:spPr>
           <a:xfrm>
-            <a:off x="6876288" y="2359152"/>
+            <a:off x="6876288" y="2139696"/>
             <a:ext cx="1536192" cy="384048"/>
           </a:xfrm>
           <a:prstGeom prst="rect">
@@ -4622,7 +4246,7 @@
               <a:buNone/>
             </a:pPr>
             <a:r>
-              <a:rPr lang="en-US" sz="1250" b="1" dirty="0">
+              <a:rPr lang="en-US" sz="1350" b="1" dirty="0">
                 <a:solidFill>
                   <a:srgbClr val="EEF3EF"/>
                 </a:solidFill>
@@ -4632,7 +4256,7 @@
               </a:rPr>
               <a:t>Entrega e histórico</a:t>
             </a:r>
-            <a:endParaRPr lang="en-US" sz="1250" dirty="0"/>
+            <a:endParaRPr lang="en-US" sz="1350" dirty="0"/>
           </a:p>
         </p:txBody>
       </p:sp>
@@ -4644,8 +4268,8 @@
         </p:nvSpPr>
         <p:spPr>
           <a:xfrm>
-            <a:off x="6876288" y="2761488"/>
-            <a:ext cx="1536192" cy="1225296"/>
+            <a:off x="6876288" y="2542032"/>
+            <a:ext cx="1536192" cy="1362456"/>
           </a:xfrm>
           <a:prstGeom prst="rect">
             <a:avLst/>
@@ -4664,7 +4288,7 @@
               <a:buNone/>
             </a:pPr>
             <a:r>
-              <a:rPr lang="en-US" sz="1000" dirty="0">
+              <a:rPr lang="en-US" sz="1150" dirty="0">
                 <a:solidFill>
                   <a:srgbClr val="C2CFC7"/>
                 </a:solidFill>
@@ -4674,7 +4298,7 @@
               </a:rPr>
               <a:t>Bot no Telegram, link rastreado e perfis, notas e envios no Supabase.</a:t>
             </a:r>
-            <a:endParaRPr lang="en-US" sz="1000" dirty="0"/>
+            <a:endParaRPr lang="en-US" sz="1150" dirty="0"/>
           </a:p>
         </p:txBody>
       </p:sp>
@@ -4785,7 +4409,7 @@
                 <a:ea typeface="Calibri" pitchFamily="34" charset="-122"/>
                 <a:cs typeface="Calibri" pitchFamily="34" charset="-120"/>
               </a:rPr>
-              <a:t>Cadastro no site, recomendação no Telegram.</a:t>
+              <a:t>Formulário no site, recomendação no Telegram.</a:t>
             </a:r>
             <a:endParaRPr lang="en-US" sz="2600" dirty="0"/>
           </a:p>
@@ -4807,8 +4431,8 @@
         </p:blipFill>
         <p:spPr>
           <a:xfrm>
-            <a:off x="881630" y="1280160"/>
-            <a:ext cx="4814419" cy="3017520"/>
+            <a:off x="989580" y="1280160"/>
+            <a:ext cx="4668528" cy="2926080"/>
           </a:xfrm>
           <a:prstGeom prst="rect">
             <a:avLst/>
@@ -4831,8 +4455,8 @@
         </p:blipFill>
         <p:spPr>
           <a:xfrm>
-            <a:off x="5952081" y="1280160"/>
-            <a:ext cx="2310289" cy="3017520"/>
+            <a:off x="5914140" y="1280160"/>
+            <a:ext cx="2240280" cy="2926080"/>
           </a:xfrm>
           <a:prstGeom prst="rect">
             <a:avLst/>
@@ -4847,24 +4471,24 @@
         </p:nvSpPr>
         <p:spPr>
           <a:xfrm>
-            <a:off x="881630" y="4407408"/>
-            <a:ext cx="4814419" cy="274320"/>
-          </a:xfrm>
-          <a:prstGeom prst="rect">
-            <a:avLst/>
-          </a:prstGeom>
-          <a:noFill/>
-          <a:ln/>
-        </p:spPr>
-        <p:txBody>
-          <a:bodyPr wrap="square" lIns="0" tIns="0" rIns="0" bIns="0" rtlCol="0" anchor="ctr"/>
-          <a:lstStyle/>
-          <a:p>
-            <a:pPr indent="0" marL="0">
-              <a:buNone/>
-            </a:pPr>
-            <a:r>
-              <a:rPr lang="en-US" sz="950" dirty="0">
+            <a:off x="989580" y="4315968"/>
+            <a:ext cx="4668528" cy="256032"/>
+          </a:xfrm>
+          <a:prstGeom prst="rect">
+            <a:avLst/>
+          </a:prstGeom>
+          <a:noFill/>
+          <a:ln/>
+        </p:spPr>
+        <p:txBody>
+          <a:bodyPr wrap="square" lIns="0" tIns="0" rIns="0" bIns="0" rtlCol="0" anchor="ctr"/>
+          <a:lstStyle/>
+          <a:p>
+            <a:pPr indent="0" marL="0">
+              <a:buNone/>
+            </a:pPr>
+            <a:r>
+              <a:rPr lang="en-US" sz="1050" dirty="0">
                 <a:solidFill>
                   <a:srgbClr val="8FA298"/>
                 </a:solidFill>
@@ -4872,9 +4496,9 @@
                 <a:ea typeface="Calibri" pitchFamily="34" charset="-122"/>
                 <a:cs typeface="Calibri" pitchFamily="34" charset="-120"/>
               </a:rPr>
-              <a:t>O perfil vem antes da conta — quatro etapas, uma única vez.</a:t>
-            </a:r>
-            <a:endParaRPr lang="en-US" sz="950" dirty="0"/>
+              <a:t>O formulário tem quatro etapas e é preenchido uma única vez.</a:t>
+            </a:r>
+            <a:endParaRPr lang="en-US" sz="1050" dirty="0"/>
           </a:p>
         </p:txBody>
       </p:sp>
@@ -4886,24 +4510,27 @@
         </p:nvSpPr>
         <p:spPr>
           <a:xfrm>
-            <a:off x="5952081" y="4407408"/>
-            <a:ext cx="3133249" cy="274320"/>
-          </a:xfrm>
-          <a:prstGeom prst="rect">
-            <a:avLst/>
-          </a:prstGeom>
-          <a:noFill/>
-          <a:ln/>
-        </p:spPr>
-        <p:txBody>
-          <a:bodyPr wrap="square" lIns="0" tIns="0" rIns="0" bIns="0" rtlCol="0" anchor="ctr"/>
-          <a:lstStyle/>
-          <a:p>
-            <a:pPr indent="0" marL="0">
-              <a:buNone/>
-            </a:pPr>
-            <a:r>
-              <a:rPr lang="en-US" sz="950" dirty="0">
+            <a:off x="5914140" y="4315968"/>
+            <a:ext cx="2681220" cy="384048"/>
+          </a:xfrm>
+          <a:prstGeom prst="rect">
+            <a:avLst/>
+          </a:prstGeom>
+          <a:noFill/>
+          <a:ln/>
+        </p:spPr>
+        <p:txBody>
+          <a:bodyPr wrap="square" lIns="0" tIns="0" rIns="0" bIns="0" rtlCol="0" anchor="ctr"/>
+          <a:lstStyle/>
+          <a:p>
+            <a:pPr indent="0" marL="0">
+              <a:lnSpc>
+                <a:spcPct val="105000"/>
+              </a:lnSpc>
+              <a:buNone/>
+            </a:pPr>
+            <a:r>
+              <a:rPr lang="en-US" sz="1050" dirty="0">
                 <a:solidFill>
                   <a:srgbClr val="8FA298"/>
                 </a:solidFill>
@@ -4913,7 +4540,67 @@
               </a:rPr>
               <a:t>A mensagem diária: nota, requisitos e o selo da fonte.</a:t>
             </a:r>
-            <a:endParaRPr lang="en-US" sz="950" dirty="0"/>
+            <a:endParaRPr lang="en-US" sz="1050" dirty="0"/>
+          </a:p>
+        </p:txBody>
+      </p:sp>
+      <p:sp>
+        <p:nvSpPr>
+          <p:cNvPr id="8" name="Text 4"/>
+          <p:cNvSpPr txBox="1"/>
+          <p:nvPr/>
+        </p:nvSpPr>
+        <p:spPr>
+          <a:xfrm>
+            <a:off x="989580" y="4645152"/>
+            <a:ext cx="8046720" cy="274320"/>
+          </a:xfrm>
+          <a:prstGeom prst="rect">
+            <a:avLst/>
+          </a:prstGeom>
+          <a:noFill/>
+          <a:ln/>
+        </p:spPr>
+        <p:txBody>
+          <a:bodyPr wrap="square" lIns="0" tIns="0" rIns="0" bIns="0" rtlCol="0" anchor="ctr"/>
+          <a:lstStyle/>
+          <a:p>
+            <a:pPr indent="0" marL="0">
+              <a:buNone/>
+            </a:pPr>
+            <a:r>
+              <a:rPr lang="en-US" sz="1150" dirty="0">
+                <a:solidFill>
+                  <a:srgbClr val="C2CFC7"/>
+                </a:solidFill>
+                <a:latin typeface="Calibri" pitchFamily="34" charset="0"/>
+                <a:ea typeface="Calibri" pitchFamily="34" charset="-122"/>
+                <a:cs typeface="Calibri" pitchFamily="34" charset="-120"/>
+              </a:rPr>
+              <a:t>O site está no ar em </a:t>
+            </a:r>
+            <a:pPr indent="0" marL="0">
+              <a:buNone/>
+            </a:pPr>
+            <a:r>
+              <a:rPr lang="en-US" sz="1150" u="sng" dirty="0">
+                <a:solidFill>
+                  <a:srgbClr val="9FD3B2"/>
+                </a:solidFill>
+                <a:latin typeface="Calibri" pitchFamily="34" charset="0"/>
+                <a:ea typeface="Calibri" pitchFamily="34" charset="-122"/>
+                <a:cs typeface="Calibri" pitchFamily="34" charset="-120"/>
+                <a:hlinkClick r:id="rId3" invalidUrl="" action="" tgtFrame="" tooltip="" history="1" highlightClick="0" endSnd="0">
+                  <a:extLst>
+                    <a:ext uri="{A12FA001-AC4F-418D-AE19-62706E023703}">
+                      <ahyp:hlinkClr xmlns:ahyp="http://schemas.microsoft.com/office/drawing/2018/hyperlinkcolor" val="tx"/>
+                    </a:ext>
+                  </a:extLst>
+                </a:hlinkClick>
+              </a:rPr>
+              <a:t>radarestagio.pages.dev</a:t>
+            </a:r>
+            <a:endParaRPr lang="en-US" sz="1150" dirty="0"/>
           </a:p>
         </p:txBody>
       </p:sp>
@@ -5038,12 +4725,12 @@
         </p:nvSpPr>
         <p:spPr>
           <a:xfrm>
-            <a:off x="548640" y="1828800"/>
-            <a:ext cx="8046720" cy="1481328"/>
+            <a:off x="548640" y="1280160"/>
+            <a:ext cx="8046720" cy="1572768"/>
           </a:xfrm>
           <a:prstGeom prst="roundRect">
             <a:avLst>
-              <a:gd name="adj" fmla="val 3704"/>
+              <a:gd name="adj" fmla="val 3488"/>
             </a:avLst>
           </a:prstGeom>
           <a:solidFill>
@@ -5065,8 +4752,8 @@
         </p:nvSpPr>
         <p:spPr>
           <a:xfrm>
-            <a:off x="2157984" y="1828800"/>
-            <a:ext cx="0" cy="1481328"/>
+            <a:off x="2157984" y="1280160"/>
+            <a:ext cx="0" cy="1572768"/>
           </a:xfrm>
           <a:prstGeom prst="line">
             <a:avLst/>
@@ -5088,8 +4775,8 @@
         </p:nvSpPr>
         <p:spPr>
           <a:xfrm>
-            <a:off x="3767328" y="1828800"/>
-            <a:ext cx="0" cy="1481328"/>
+            <a:off x="3767328" y="1280160"/>
+            <a:ext cx="0" cy="1572768"/>
           </a:xfrm>
           <a:prstGeom prst="line">
             <a:avLst/>
@@ -5111,8 +4798,8 @@
         </p:nvSpPr>
         <p:spPr>
           <a:xfrm>
-            <a:off x="5376672" y="1828800"/>
-            <a:ext cx="0" cy="1481328"/>
+            <a:off x="5376672" y="1280160"/>
+            <a:ext cx="0" cy="1572768"/>
           </a:xfrm>
           <a:prstGeom prst="line">
             <a:avLst/>
@@ -5134,8 +4821,8 @@
         </p:nvSpPr>
         <p:spPr>
           <a:xfrm>
-            <a:off x="6986016" y="1828800"/>
-            <a:ext cx="0" cy="1481328"/>
+            <a:off x="6986016" y="1280160"/>
+            <a:ext cx="0" cy="1572768"/>
           </a:xfrm>
           <a:prstGeom prst="line">
             <a:avLst/>
@@ -5157,7 +4844,7 @@
         </p:nvSpPr>
         <p:spPr>
           <a:xfrm>
-            <a:off x="731520" y="1975104"/>
+            <a:off x="731520" y="1426464"/>
             <a:ext cx="1243584" cy="182880"/>
           </a:xfrm>
           <a:prstGeom prst="rect">
@@ -5196,7 +4883,7 @@
         </p:nvSpPr>
         <p:spPr>
           <a:xfrm>
-            <a:off x="731520" y="2176272"/>
+            <a:off x="731520" y="1627632"/>
             <a:ext cx="1243584" cy="457200"/>
           </a:xfrm>
           <a:prstGeom prst="rect">
@@ -5216,7 +4903,7 @@
               <a:buNone/>
             </a:pPr>
             <a:r>
-              <a:rPr lang="en-US" sz="1250" b="1" dirty="0">
+              <a:rPr lang="en-US" sz="1300" b="1" dirty="0">
                 <a:solidFill>
                   <a:srgbClr val="EEF3EF"/>
                 </a:solidFill>
@@ -5226,7 +4913,7 @@
               </a:rPr>
               <a:t>Coleta</a:t>
             </a:r>
-            <a:endParaRPr lang="en-US" sz="1250" dirty="0"/>
+            <a:endParaRPr lang="en-US" sz="1300" dirty="0"/>
           </a:p>
         </p:txBody>
       </p:sp>
@@ -5238,8 +4925,8 @@
         </p:nvSpPr>
         <p:spPr>
           <a:xfrm>
-            <a:off x="731520" y="2670048"/>
-            <a:ext cx="1243584" cy="530352"/>
+            <a:off x="731520" y="2121408"/>
+            <a:ext cx="1243584" cy="621792"/>
           </a:xfrm>
           <a:prstGeom prst="rect">
             <a:avLst/>
@@ -5258,7 +4945,7 @@
               <a:buNone/>
             </a:pPr>
             <a:r>
-              <a:rPr lang="en-US" sz="900" dirty="0">
+              <a:rPr lang="en-US" sz="950" dirty="0">
                 <a:solidFill>
                   <a:srgbClr val="5CB584"/>
                 </a:solidFill>
@@ -5268,7 +4955,7 @@
               </a:rPr>
               <a:t>733 vagas</a:t>
             </a:r>
-            <a:endParaRPr lang="en-US" sz="900" dirty="0"/>
+            <a:endParaRPr lang="en-US" sz="950" dirty="0"/>
           </a:p>
           <a:p>
             <a:pPr indent="0" marL="0">
@@ -5278,7 +4965,7 @@
               <a:buNone/>
             </a:pPr>
             <a:r>
-              <a:rPr lang="en-US" sz="900" dirty="0">
+              <a:rPr lang="en-US" sz="950" dirty="0">
                 <a:solidFill>
                   <a:srgbClr val="5CB584"/>
                 </a:solidFill>
@@ -5288,7 +4975,7 @@
               </a:rPr>
               <a:t>16 requisições</a:t>
             </a:r>
-            <a:endParaRPr lang="en-US" sz="900" dirty="0"/>
+            <a:endParaRPr lang="en-US" sz="950" dirty="0"/>
           </a:p>
         </p:txBody>
       </p:sp>
@@ -5300,7 +4987,7 @@
         </p:nvSpPr>
         <p:spPr>
           <a:xfrm>
-            <a:off x="2340864" y="1975104"/>
+            <a:off x="2340864" y="1426464"/>
             <a:ext cx="1243584" cy="182880"/>
           </a:xfrm>
           <a:prstGeom prst="rect">
@@ -5339,7 +5026,7 @@
         </p:nvSpPr>
         <p:spPr>
           <a:xfrm>
-            <a:off x="2340864" y="2176272"/>
+            <a:off x="2340864" y="1627632"/>
             <a:ext cx="1243584" cy="457200"/>
           </a:xfrm>
           <a:prstGeom prst="rect">
@@ -5359,7 +5046,7 @@
               <a:buNone/>
             </a:pPr>
             <a:r>
-              <a:rPr lang="en-US" sz="1250" b="1" dirty="0">
+              <a:rPr lang="en-US" sz="1300" b="1" dirty="0">
                 <a:solidFill>
                   <a:srgbClr val="EEF3EF"/>
                 </a:solidFill>
@@ -5369,7 +5056,7 @@
               </a:rPr>
               <a:t>Dedupe e pré-filtro</a:t>
             </a:r>
-            <a:endParaRPr lang="en-US" sz="1250" dirty="0"/>
+            <a:endParaRPr lang="en-US" sz="1300" dirty="0"/>
           </a:p>
         </p:txBody>
       </p:sp>
@@ -5381,8 +5068,8 @@
         </p:nvSpPr>
         <p:spPr>
           <a:xfrm>
-            <a:off x="2340864" y="2670048"/>
-            <a:ext cx="1243584" cy="530352"/>
+            <a:off x="2340864" y="2121408"/>
+            <a:ext cx="1243584" cy="621792"/>
           </a:xfrm>
           <a:prstGeom prst="rect">
             <a:avLst/>
@@ -5401,7 +5088,7 @@
               <a:buNone/>
             </a:pPr>
             <a:r>
-              <a:rPr lang="en-US" sz="900" dirty="0">
+              <a:rPr lang="en-US" sz="950" dirty="0">
                 <a:solidFill>
                   <a:srgbClr val="5CB584"/>
                 </a:solidFill>
@@ -5411,7 +5098,7 @@
               </a:rPr>
               <a:t>35 candidatas</a:t>
             </a:r>
-            <a:endParaRPr lang="en-US" sz="900" dirty="0"/>
+            <a:endParaRPr lang="en-US" sz="950" dirty="0"/>
           </a:p>
           <a:p>
             <a:pPr indent="0" marL="0">
@@ -5421,7 +5108,7 @@
               <a:buNone/>
             </a:pPr>
             <a:r>
-              <a:rPr lang="en-US" sz="900" dirty="0">
+              <a:rPr lang="en-US" sz="950" dirty="0">
                 <a:solidFill>
                   <a:srgbClr val="5CB584"/>
                 </a:solidFill>
@@ -5431,7 +5118,7 @@
               </a:rPr>
               <a:t>por perfil</a:t>
             </a:r>
-            <a:endParaRPr lang="en-US" sz="900" dirty="0"/>
+            <a:endParaRPr lang="en-US" sz="950" dirty="0"/>
           </a:p>
         </p:txBody>
       </p:sp>
@@ -5443,8 +5130,8 @@
         </p:nvSpPr>
         <p:spPr>
           <a:xfrm>
-            <a:off x="3785616" y="1847088"/>
-            <a:ext cx="1572768" cy="1444752"/>
+            <a:off x="3785616" y="1298448"/>
+            <a:ext cx="1572768" cy="1536192"/>
           </a:xfrm>
           <a:prstGeom prst="rect">
             <a:avLst/>
@@ -5468,7 +5155,7 @@
         </p:nvSpPr>
         <p:spPr>
           <a:xfrm>
-            <a:off x="3950208" y="1975104"/>
+            <a:off x="3950208" y="1426464"/>
             <a:ext cx="1243584" cy="182880"/>
           </a:xfrm>
           <a:prstGeom prst="rect">
@@ -5507,7 +5194,7 @@
         </p:nvSpPr>
         <p:spPr>
           <a:xfrm>
-            <a:off x="3950208" y="2176272"/>
+            <a:off x="3950208" y="1627632"/>
             <a:ext cx="1243584" cy="457200"/>
           </a:xfrm>
           <a:prstGeom prst="rect">
@@ -5527,7 +5214,7 @@
               <a:buNone/>
             </a:pPr>
             <a:r>
-              <a:rPr lang="en-US" sz="1250" b="1" dirty="0">
+              <a:rPr lang="en-US" sz="1300" b="1" dirty="0">
                 <a:solidFill>
                   <a:srgbClr val="9FD3B2"/>
                 </a:solidFill>
@@ -5537,7 +5224,7 @@
               </a:rPr>
               <a:t>Extração de fatos</a:t>
             </a:r>
-            <a:endParaRPr lang="en-US" sz="1250" dirty="0"/>
+            <a:endParaRPr lang="en-US" sz="1300" dirty="0"/>
           </a:p>
         </p:txBody>
       </p:sp>
@@ -5549,8 +5236,8 @@
         </p:nvSpPr>
         <p:spPr>
           <a:xfrm>
-            <a:off x="3950208" y="2670048"/>
-            <a:ext cx="1243584" cy="530352"/>
+            <a:off x="3950208" y="2121408"/>
+            <a:ext cx="1243584" cy="621792"/>
           </a:xfrm>
           <a:prstGeom prst="rect">
             <a:avLst/>
@@ -5569,7 +5256,7 @@
               <a:buNone/>
             </a:pPr>
             <a:r>
-              <a:rPr lang="en-US" sz="900" dirty="0">
+              <a:rPr lang="en-US" sz="950" dirty="0">
                 <a:solidFill>
                   <a:srgbClr val="5CB584"/>
                 </a:solidFill>
@@ -5579,7 +5266,7 @@
               </a:rPr>
               <a:t>4 requisições</a:t>
             </a:r>
-            <a:endParaRPr lang="en-US" sz="900" dirty="0"/>
+            <a:endParaRPr lang="en-US" sz="950" dirty="0"/>
           </a:p>
           <a:p>
             <a:pPr indent="0" marL="0">
@@ -5589,7 +5276,7 @@
               <a:buNone/>
             </a:pPr>
             <a:r>
-              <a:rPr lang="en-US" sz="900" dirty="0">
+              <a:rPr lang="en-US" sz="950" dirty="0">
                 <a:solidFill>
                   <a:srgbClr val="5CB584"/>
                 </a:solidFill>
@@ -5599,7 +5286,7 @@
               </a:rPr>
               <a:t>ao Gemini</a:t>
             </a:r>
-            <a:endParaRPr lang="en-US" sz="900" dirty="0"/>
+            <a:endParaRPr lang="en-US" sz="950" dirty="0"/>
           </a:p>
         </p:txBody>
       </p:sp>
@@ -5611,7 +5298,7 @@
         </p:nvSpPr>
         <p:spPr>
           <a:xfrm>
-            <a:off x="5559552" y="1975104"/>
+            <a:off x="5559552" y="1426464"/>
             <a:ext cx="1243584" cy="182880"/>
           </a:xfrm>
           <a:prstGeom prst="rect">
@@ -5650,7 +5337,7 @@
         </p:nvSpPr>
         <p:spPr>
           <a:xfrm>
-            <a:off x="5559552" y="2176272"/>
+            <a:off x="5559552" y="1627632"/>
             <a:ext cx="1243584" cy="457200"/>
           </a:xfrm>
           <a:prstGeom prst="rect">
@@ -5670,7 +5357,7 @@
               <a:buNone/>
             </a:pPr>
             <a:r>
-              <a:rPr lang="en-US" sz="1250" b="1" dirty="0">
+              <a:rPr lang="en-US" sz="1300" b="1" dirty="0">
                 <a:solidFill>
                   <a:srgbClr val="EEF3EF"/>
                 </a:solidFill>
@@ -5680,7 +5367,7 @@
               </a:rPr>
               <a:t>Nota e ranking</a:t>
             </a:r>
-            <a:endParaRPr lang="en-US" sz="1250" dirty="0"/>
+            <a:endParaRPr lang="en-US" sz="1300" dirty="0"/>
           </a:p>
         </p:txBody>
       </p:sp>
@@ -5692,8 +5379,8 @@
         </p:nvSpPr>
         <p:spPr>
           <a:xfrm>
-            <a:off x="5559552" y="2670048"/>
-            <a:ext cx="1243584" cy="530352"/>
+            <a:off x="5559552" y="2121408"/>
+            <a:ext cx="1243584" cy="621792"/>
           </a:xfrm>
           <a:prstGeom prst="rect">
             <a:avLst/>
@@ -5712,7 +5399,7 @@
               <a:buNone/>
             </a:pPr>
             <a:r>
-              <a:rPr lang="en-US" sz="900" dirty="0">
+              <a:rPr lang="en-US" sz="950" dirty="0">
                 <a:solidFill>
                   <a:srgbClr val="5CB584"/>
                 </a:solidFill>
@@ -5722,7 +5409,7 @@
               </a:rPr>
               <a:t>23 vagas</a:t>
             </a:r>
-            <a:endParaRPr lang="en-US" sz="900" dirty="0"/>
+            <a:endParaRPr lang="en-US" sz="950" dirty="0"/>
           </a:p>
           <a:p>
             <a:pPr indent="0" marL="0">
@@ -5732,7 +5419,7 @@
               <a:buNone/>
             </a:pPr>
             <a:r>
-              <a:rPr lang="en-US" sz="900" dirty="0">
+              <a:rPr lang="en-US" sz="950" dirty="0">
                 <a:solidFill>
                   <a:srgbClr val="5CB584"/>
                 </a:solidFill>
@@ -5742,7 +5429,7 @@
               </a:rPr>
               <a:t>para 4 pessoas</a:t>
             </a:r>
-            <a:endParaRPr lang="en-US" sz="900" dirty="0"/>
+            <a:endParaRPr lang="en-US" sz="950" dirty="0"/>
           </a:p>
         </p:txBody>
       </p:sp>
@@ -5754,7 +5441,7 @@
         </p:nvSpPr>
         <p:spPr>
           <a:xfrm>
-            <a:off x="7168896" y="1975104"/>
+            <a:off x="7168896" y="1426464"/>
             <a:ext cx="1243584" cy="182880"/>
           </a:xfrm>
           <a:prstGeom prst="rect">
@@ -5793,7 +5480,7 @@
         </p:nvSpPr>
         <p:spPr>
           <a:xfrm>
-            <a:off x="7168896" y="2176272"/>
+            <a:off x="7168896" y="1627632"/>
             <a:ext cx="1243584" cy="457200"/>
           </a:xfrm>
           <a:prstGeom prst="rect">
@@ -5813,7 +5500,7 @@
               <a:buNone/>
             </a:pPr>
             <a:r>
-              <a:rPr lang="en-US" sz="1250" b="1" dirty="0">
+              <a:rPr lang="en-US" sz="1300" b="1" dirty="0">
                 <a:solidFill>
                   <a:srgbClr val="EEF3EF"/>
                 </a:solidFill>
@@ -5823,7 +5510,7 @@
               </a:rPr>
               <a:t>Telegram</a:t>
             </a:r>
-            <a:endParaRPr lang="en-US" sz="1250" dirty="0"/>
+            <a:endParaRPr lang="en-US" sz="1300" dirty="0"/>
           </a:p>
         </p:txBody>
       </p:sp>
@@ -5835,8 +5522,8 @@
         </p:nvSpPr>
         <p:spPr>
           <a:xfrm>
-            <a:off x="7168896" y="2670048"/>
-            <a:ext cx="1243584" cy="530352"/>
+            <a:off x="7168896" y="2121408"/>
+            <a:ext cx="1243584" cy="621792"/>
           </a:xfrm>
           <a:prstGeom prst="rect">
             <a:avLst/>
@@ -5855,7 +5542,7 @@
               <a:buNone/>
             </a:pPr>
             <a:r>
-              <a:rPr lang="en-US" sz="900" dirty="0">
+              <a:rPr lang="en-US" sz="950" dirty="0">
                 <a:solidFill>
                   <a:srgbClr val="5CB584"/>
                 </a:solidFill>
@@ -5865,7 +5552,7 @@
               </a:rPr>
               <a:t>a pessoa abre</a:t>
             </a:r>
-            <a:endParaRPr lang="en-US" sz="900" dirty="0"/>
+            <a:endParaRPr lang="en-US" sz="950" dirty="0"/>
           </a:p>
           <a:p>
             <a:pPr indent="0" marL="0">
@@ -5875,7 +5562,7 @@
               <a:buNone/>
             </a:pPr>
             <a:r>
-              <a:rPr lang="en-US" sz="900" dirty="0">
+              <a:rPr lang="en-US" sz="950" dirty="0">
                 <a:solidFill>
                   <a:srgbClr val="5CB584"/>
                 </a:solidFill>
@@ -5885,7 +5572,7 @@
               </a:rPr>
               <a:t>e responde</a:t>
             </a:r>
-            <a:endParaRPr lang="en-US" sz="900" dirty="0"/>
+            <a:endParaRPr lang="en-US" sz="950" dirty="0"/>
           </a:p>
         </p:txBody>
       </p:sp>
@@ -5897,7 +5584,7 @@
         </p:nvSpPr>
         <p:spPr>
           <a:xfrm>
-            <a:off x="548640" y="3584448"/>
+            <a:off x="548640" y="3035808"/>
             <a:ext cx="8046720" cy="566928"/>
           </a:xfrm>
           <a:prstGeom prst="rect">
@@ -5917,7 +5604,7 @@
               <a:buNone/>
             </a:pPr>
             <a:r>
-              <a:rPr lang="en-US" sz="1200" dirty="0">
+              <a:rPr lang="en-US" sz="1300" dirty="0">
                 <a:solidFill>
                   <a:srgbClr val="C2CFC7"/>
                 </a:solidFill>
@@ -5927,7 +5614,7 @@
               </a:rPr>
               <a:t>A extração é por vaga, não por pessoa: a mesma leitura serve todos os perfis, e por isso um usuário novo quase não custa. Números da execução de 28/09.</a:t>
             </a:r>
-            <a:endParaRPr lang="en-US" sz="1200" dirty="0"/>
+            <a:endParaRPr lang="en-US" sz="1300" dirty="0"/>
           </a:p>
         </p:txBody>
       </p:sp>
@@ -6081,7 +5768,7 @@
                         <a:buNone/>
                       </a:pPr>
                       <a:r>
-                        <a:rPr lang="en-US" sz="800" dirty="0">
+                        <a:rPr lang="en-US" sz="850" dirty="0">
                           <a:solidFill>
                             <a:srgbClr val="8FA298"/>
                           </a:solidFill>
@@ -6091,7 +5778,7 @@
                         </a:rPr>
                         <a:t>EMPRESA</a:t>
                       </a:r>
-                      <a:endParaRPr lang="en-US" sz="800" dirty="0">
+                      <a:endParaRPr lang="en-US" sz="850" dirty="0">
                         <a:latin typeface="Courier New" charset="0"/>
                         <a:ea typeface="Courier New" charset="0"/>
                         <a:cs typeface="Courier New" charset="0"/>
@@ -6149,7 +5836,7 @@
                         <a:buNone/>
                       </a:pPr>
                       <a:r>
-                        <a:rPr lang="en-US" sz="800" dirty="0">
+                        <a:rPr lang="en-US" sz="850" dirty="0">
                           <a:solidFill>
                             <a:srgbClr val="8FA298"/>
                           </a:solidFill>
@@ -6159,7 +5846,7 @@
                         </a:rPr>
                         <a:t>O QUE FEZ</a:t>
                       </a:r>
-                      <a:endParaRPr lang="en-US" sz="800" dirty="0">
+                      <a:endParaRPr lang="en-US" sz="850" dirty="0">
                         <a:latin typeface="Courier New" charset="0"/>
                         <a:ea typeface="Courier New" charset="0"/>
                         <a:cs typeface="Courier New" charset="0"/>
@@ -6217,7 +5904,7 @@
                         <a:buNone/>
                       </a:pPr>
                       <a:r>
-                        <a:rPr lang="en-US" sz="800" dirty="0">
+                        <a:rPr lang="en-US" sz="850" dirty="0">
                           <a:solidFill>
                             <a:srgbClr val="8FA298"/>
                           </a:solidFill>
@@ -6227,7 +5914,7 @@
                         </a:rPr>
                         <a:t>RESULTADO</a:t>
                       </a:r>
-                      <a:endParaRPr lang="en-US" sz="800" dirty="0">
+                      <a:endParaRPr lang="en-US" sz="850" dirty="0">
                         <a:latin typeface="Courier New" charset="0"/>
                         <a:ea typeface="Courier New" charset="0"/>
                         <a:cs typeface="Courier New" charset="0"/>
@@ -6287,7 +5974,7 @@
                         <a:buNone/>
                       </a:pPr>
                       <a:r>
-                        <a:rPr lang="en-US" sz="1000" b="1" dirty="0">
+                        <a:rPr lang="en-US" sz="1100" b="1" dirty="0">
                           <a:solidFill>
                             <a:srgbClr val="EEF3EF"/>
                           </a:solidFill>
@@ -6297,7 +5984,7 @@
                         </a:rPr>
                         <a:t>Unilever</a:t>
                       </a:r>
-                      <a:endParaRPr lang="en-US" sz="1000" dirty="0">
+                      <a:endParaRPr lang="en-US" sz="1100" dirty="0">
                         <a:latin typeface="Calibri" charset="0"/>
                         <a:ea typeface="Calibri" charset="0"/>
                         <a:cs typeface="Calibri" charset="0"/>
@@ -6355,7 +6042,7 @@
                         <a:buNone/>
                       </a:pPr>
                       <a:r>
-                        <a:rPr lang="en-US" sz="1000" dirty="0">
+                        <a:rPr lang="en-US" sz="1100" dirty="0">
                           <a:solidFill>
                             <a:srgbClr val="C2CFC7"/>
                           </a:solidFill>
@@ -6365,7 +6052,7 @@
                         </a:rPr>
                         <a:t>Triagem de 250 mil candidaturas por ciclo com entrevista em vídeo e jogos cognitivos</a:t>
                       </a:r>
-                      <a:endParaRPr lang="en-US" sz="1000" dirty="0">
+                      <a:endParaRPr lang="en-US" sz="1100" dirty="0">
                         <a:latin typeface="Calibri" charset="0"/>
                         <a:ea typeface="Calibri" charset="0"/>
                         <a:cs typeface="Calibri" charset="0"/>
@@ -6423,7 +6110,7 @@
                         <a:buNone/>
                       </a:pPr>
                       <a:r>
-                        <a:rPr lang="en-US" sz="1000" dirty="0">
+                        <a:rPr lang="en-US" sz="1100" dirty="0">
                           <a:solidFill>
                             <a:srgbClr val="C2CFC7"/>
                           </a:solidFill>
@@ -6433,7 +6120,7 @@
                         </a:rPr>
                         <a:t>Contratação de 4 meses para 4 semanas; 50 mil horas de entrevista economizadas</a:t>
                       </a:r>
-                      <a:endParaRPr lang="en-US" sz="1000" dirty="0">
+                      <a:endParaRPr lang="en-US" sz="1100" dirty="0">
                         <a:latin typeface="Calibri" charset="0"/>
                         <a:ea typeface="Calibri" charset="0"/>
                         <a:cs typeface="Calibri" charset="0"/>
@@ -6493,7 +6180,7 @@
                         <a:buNone/>
                       </a:pPr>
                       <a:r>
-                        <a:rPr lang="en-US" sz="1000" b="1" dirty="0">
+                        <a:rPr lang="en-US" sz="1100" b="1" dirty="0">
                           <a:solidFill>
                             <a:srgbClr val="EEF3EF"/>
                           </a:solidFill>
@@ -6503,7 +6190,7 @@
                         </a:rPr>
                         <a:t>Gupy</a:t>
                       </a:r>
-                      <a:endParaRPr lang="en-US" sz="1000" dirty="0">
+                      <a:endParaRPr lang="en-US" sz="1100" dirty="0">
                         <a:latin typeface="Calibri" charset="0"/>
                         <a:ea typeface="Calibri" charset="0"/>
                         <a:cs typeface="Calibri" charset="0"/>
@@ -6561,7 +6248,7 @@
                         <a:buNone/>
                       </a:pPr>
                       <a:r>
-                        <a:rPr lang="en-US" sz="1000" dirty="0">
+                        <a:rPr lang="en-US" sz="1100" dirty="0">
                           <a:solidFill>
                             <a:srgbClr val="C2CFC7"/>
                           </a:solidFill>
@@ -6571,7 +6258,7 @@
                         </a:rPr>
                         <a:t>ATS brasileiro com NLP na ordenação de candidatos, em 2.300 empresas clientes</a:t>
                       </a:r>
-                      <a:endParaRPr lang="en-US" sz="1000" dirty="0">
+                      <a:endParaRPr lang="en-US" sz="1100" dirty="0">
                         <a:latin typeface="Calibri" charset="0"/>
                         <a:ea typeface="Calibri" charset="0"/>
                         <a:cs typeface="Calibri" charset="0"/>
@@ -6629,7 +6316,7 @@
                         <a:buNone/>
                       </a:pPr>
                       <a:r>
-                        <a:rPr lang="en-US" sz="1000" dirty="0">
+                        <a:rPr lang="en-US" sz="1100" dirty="0">
                           <a:solidFill>
                             <a:srgbClr val="C2CFC7"/>
                           </a:solidFill>
@@ -6639,7 +6326,7 @@
                         </a:rPr>
                         <a:t>480 mil vagas preenchidas em 2021, com redução de até 80% no tempo de contratação</a:t>
                       </a:r>
-                      <a:endParaRPr lang="en-US" sz="1000" dirty="0">
+                      <a:endParaRPr lang="en-US" sz="1100" dirty="0">
                         <a:latin typeface="Calibri" charset="0"/>
                         <a:ea typeface="Calibri" charset="0"/>
                         <a:cs typeface="Calibri" charset="0"/>
@@ -6699,7 +6386,7 @@
                         <a:buNone/>
                       </a:pPr>
                       <a:r>
-                        <a:rPr lang="en-US" sz="1000" b="1" dirty="0">
+                        <a:rPr lang="en-US" sz="1100" b="1" dirty="0">
                           <a:solidFill>
                             <a:srgbClr val="EEF3EF"/>
                           </a:solidFill>
@@ -6709,7 +6396,7 @@
                         </a:rPr>
                         <a:t>LinkedIn</a:t>
                       </a:r>
-                      <a:endParaRPr lang="en-US" sz="1000" dirty="0">
+                      <a:endParaRPr lang="en-US" sz="1100" dirty="0">
                         <a:latin typeface="Calibri" charset="0"/>
                         <a:ea typeface="Calibri" charset="0"/>
                         <a:cs typeface="Calibri" charset="0"/>
@@ -6767,7 +6454,7 @@
                         <a:buNone/>
                       </a:pPr>
                       <a:r>
-                        <a:rPr lang="en-US" sz="1000" dirty="0">
+                        <a:rPr lang="en-US" sz="1100" dirty="0">
                           <a:solidFill>
                             <a:srgbClr val="C2CFC7"/>
                           </a:solidFill>
@@ -6777,7 +6464,7 @@
                         </a:rPr>
                         <a:t>Casa 50 milhões de vagas com cada usuário num funil de quatro estágios</a:t>
                       </a:r>
-                      <a:endParaRPr lang="en-US" sz="1000" dirty="0">
+                      <a:endParaRPr lang="en-US" sz="1100" dirty="0">
                         <a:latin typeface="Calibri" charset="0"/>
                         <a:ea typeface="Calibri" charset="0"/>
                         <a:cs typeface="Calibri" charset="0"/>
@@ -6835,7 +6522,7 @@
                         <a:buNone/>
                       </a:pPr>
                       <a:r>
-                        <a:rPr lang="en-US" sz="1000" dirty="0">
+                        <a:rPr lang="en-US" sz="1100" dirty="0">
                           <a:solidFill>
                             <a:srgbClr val="C2CFC7"/>
                           </a:solidFill>
@@ -6845,7 +6532,7 @@
                         </a:rPr>
                         <a:t>Lição da própria engenharia: otimizar por clique premia título sensacionalista</a:t>
                       </a:r>
-                      <a:endParaRPr lang="en-US" sz="1000" dirty="0">
+                      <a:endParaRPr lang="en-US" sz="1100" dirty="0">
                         <a:latin typeface="Calibri" charset="0"/>
                         <a:ea typeface="Calibri" charset="0"/>
                         <a:cs typeface="Calibri" charset="0"/>
@@ -6907,7 +6594,7 @@
         </p:nvSpPr>
         <p:spPr>
           <a:xfrm>
-            <a:off x="548640" y="3584448"/>
+            <a:off x="548640" y="3529584"/>
             <a:ext cx="8046720" cy="566928"/>
           </a:xfrm>
           <a:prstGeom prst="rect">
@@ -6927,7 +6614,7 @@
               <a:buNone/>
             </a:pPr>
             <a:r>
-              <a:rPr lang="en-US" sz="1200" dirty="0">
+              <a:rPr lang="en-US" sz="1300" dirty="0">
                 <a:solidFill>
                   <a:srgbClr val="C2CFC7"/>
                 </a:solidFill>
@@ -6937,7 +6624,7 @@
               </a:rPr>
               <a:t>Todos filtram pessoas para a empresa. O Radar inverte o lado: filtra vagas para o estudante, então nunca descarta alguém — no máximo deixa de recomendar uma vaga.</a:t>
             </a:r>
-            <a:endParaRPr lang="en-US" sz="1200" dirty="0"/>
+            <a:endParaRPr lang="en-US" sz="1300" dirty="0"/>
           </a:p>
         </p:txBody>
       </p:sp>
@@ -6949,7 +6636,7 @@
         </p:nvSpPr>
         <p:spPr>
           <a:xfrm>
-            <a:off x="548640" y="4315968"/>
+            <a:off x="548640" y="4224528"/>
             <a:ext cx="8046720" cy="219456"/>
           </a:xfrm>
           <a:prstGeom prst="rect">
@@ -7130,7 +6817,7 @@
                         <a:buNone/>
                       </a:pPr>
                       <a:r>
-                        <a:rPr lang="en-US" sz="800" dirty="0">
+                        <a:rPr lang="en-US" sz="850" dirty="0">
                           <a:solidFill>
                             <a:srgbClr val="8FA298"/>
                           </a:solidFill>
@@ -7140,7 +6827,7 @@
                         </a:rPr>
                         <a:t>ETAPA</a:t>
                       </a:r>
-                      <a:endParaRPr lang="en-US" sz="800" dirty="0">
+                      <a:endParaRPr lang="en-US" sz="850" dirty="0">
                         <a:latin typeface="Courier New" charset="0"/>
                         <a:ea typeface="Courier New" charset="0"/>
                         <a:cs typeface="Courier New" charset="0"/>
@@ -7198,7 +6885,7 @@
                         <a:buNone/>
                       </a:pPr>
                       <a:r>
-                        <a:rPr lang="en-US" sz="800" dirty="0">
+                        <a:rPr lang="en-US" sz="850" dirty="0">
                           <a:solidFill>
                             <a:srgbClr val="8FA298"/>
                           </a:solidFill>
@@ -7208,7 +6895,7 @@
                         </a:rPr>
                         <a:t>SEM O RADAR</a:t>
                       </a:r>
-                      <a:endParaRPr lang="en-US" sz="800" dirty="0">
+                      <a:endParaRPr lang="en-US" sz="850" dirty="0">
                         <a:latin typeface="Courier New" charset="0"/>
                         <a:ea typeface="Courier New" charset="0"/>
                         <a:cs typeface="Courier New" charset="0"/>
@@ -7266,7 +6953,7 @@
                         <a:buNone/>
                       </a:pPr>
                       <a:r>
-                        <a:rPr lang="en-US" sz="800" dirty="0">
+                        <a:rPr lang="en-US" sz="850" dirty="0">
                           <a:solidFill>
                             <a:srgbClr val="5CB584"/>
                           </a:solidFill>
@@ -7276,7 +6963,7 @@
                         </a:rPr>
                         <a:t>COM O RADAR</a:t>
                       </a:r>
-                      <a:endParaRPr lang="en-US" sz="800" dirty="0">
+                      <a:endParaRPr lang="en-US" sz="850" dirty="0">
                         <a:latin typeface="Courier New" charset="0"/>
                         <a:ea typeface="Courier New" charset="0"/>
                         <a:cs typeface="Courier New" charset="0"/>
@@ -7336,7 +7023,7 @@
                         <a:buNone/>
                       </a:pPr>
                       <a:r>
-                        <a:rPr lang="en-US" sz="1000" b="1" dirty="0">
+                        <a:rPr lang="en-US" sz="1100" b="1" dirty="0">
                           <a:solidFill>
                             <a:srgbClr val="EEF3EF"/>
                           </a:solidFill>
@@ -7346,7 +7033,7 @@
                         </a:rPr>
                         <a:t>Procurar</a:t>
                       </a:r>
-                      <a:endParaRPr lang="en-US" sz="1000" dirty="0">
+                      <a:endParaRPr lang="en-US" sz="1100" dirty="0">
                         <a:latin typeface="Calibri" charset="0"/>
                         <a:ea typeface="Calibri" charset="0"/>
                         <a:cs typeface="Calibri" charset="0"/>
@@ -7404,7 +7091,7 @@
                         <a:buNone/>
                       </a:pPr>
                       <a:r>
-                        <a:rPr lang="en-US" sz="1000" dirty="0">
+                        <a:rPr lang="en-US" sz="1100" dirty="0">
                           <a:solidFill>
                             <a:srgbClr val="C2CFC7"/>
                           </a:solidFill>
@@ -7414,7 +7101,7 @@
                         </a:rPr>
                         <a:t>Abrir portais e repetir a busca todo dia</a:t>
                       </a:r>
-                      <a:endParaRPr lang="en-US" sz="1000" dirty="0">
+                      <a:endParaRPr lang="en-US" sz="1100" dirty="0">
                         <a:latin typeface="Calibri" charset="0"/>
                         <a:ea typeface="Calibri" charset="0"/>
                         <a:cs typeface="Calibri" charset="0"/>
@@ -7472,7 +7159,7 @@
                         <a:buNone/>
                       </a:pPr>
                       <a:r>
-                        <a:rPr lang="en-US" sz="1000" dirty="0">
+                        <a:rPr lang="en-US" sz="1100" dirty="0">
                           <a:solidFill>
                             <a:srgbClr val="EEF3EF"/>
                           </a:solidFill>
@@ -7482,7 +7169,7 @@
                         </a:rPr>
                         <a:t>Uma execução diária, sem ação do estudante</a:t>
                       </a:r>
-                      <a:endParaRPr lang="en-US" sz="1000" dirty="0">
+                      <a:endParaRPr lang="en-US" sz="1100" dirty="0">
                         <a:latin typeface="Calibri" charset="0"/>
                         <a:ea typeface="Calibri" charset="0"/>
                         <a:cs typeface="Calibri" charset="0"/>
@@ -7542,7 +7229,7 @@
                         <a:buNone/>
                       </a:pPr>
                       <a:r>
-                        <a:rPr lang="en-US" sz="1000" b="1" dirty="0">
+                        <a:rPr lang="en-US" sz="1100" b="1" dirty="0">
                           <a:solidFill>
                             <a:srgbClr val="EEF3EF"/>
                           </a:solidFill>
@@ -7552,7 +7239,7 @@
                         </a:rPr>
                         <a:t>Triar</a:t>
                       </a:r>
-                      <a:endParaRPr lang="en-US" sz="1000" dirty="0">
+                      <a:endParaRPr lang="en-US" sz="1100" dirty="0">
                         <a:latin typeface="Calibri" charset="0"/>
                         <a:ea typeface="Calibri" charset="0"/>
                         <a:cs typeface="Calibri" charset="0"/>
@@ -7610,7 +7297,7 @@
                         <a:buNone/>
                       </a:pPr>
                       <a:r>
-                        <a:rPr lang="en-US" sz="1000" dirty="0">
+                        <a:rPr lang="en-US" sz="1100" dirty="0">
                           <a:solidFill>
                             <a:srgbClr val="C2CFC7"/>
                           </a:solidFill>
@@ -7620,7 +7307,7 @@
                         </a:rPr>
                         <a:t>Ler anúncio por anúncio para ver se o curso é aceito</a:t>
                       </a:r>
-                      <a:endParaRPr lang="en-US" sz="1000" dirty="0">
+                      <a:endParaRPr lang="en-US" sz="1100" dirty="0">
                         <a:latin typeface="Calibri" charset="0"/>
                         <a:ea typeface="Calibri" charset="0"/>
                         <a:cs typeface="Calibri" charset="0"/>
@@ -7678,7 +7365,7 @@
                         <a:buNone/>
                       </a:pPr>
                       <a:r>
-                        <a:rPr lang="en-US" sz="1000" dirty="0">
+                        <a:rPr lang="en-US" sz="1100" dirty="0">
                           <a:solidFill>
                             <a:srgbClr val="EEF3EF"/>
                           </a:solidFill>
@@ -7688,7 +7375,7 @@
                         </a:rPr>
                         <a:t>733 anúncios viram 7, já conferidos</a:t>
                       </a:r>
-                      <a:endParaRPr lang="en-US" sz="1000" dirty="0">
+                      <a:endParaRPr lang="en-US" sz="1100" dirty="0">
                         <a:latin typeface="Calibri" charset="0"/>
                         <a:ea typeface="Calibri" charset="0"/>
                         <a:cs typeface="Calibri" charset="0"/>
@@ -7748,7 +7435,7 @@
                         <a:buNone/>
                       </a:pPr>
                       <a:r>
-                        <a:rPr lang="en-US" sz="1000" b="1" dirty="0">
+                        <a:rPr lang="en-US" sz="1100" b="1" dirty="0">
                           <a:solidFill>
                             <a:srgbClr val="EEF3EF"/>
                           </a:solidFill>
@@ -7758,7 +7445,7 @@
                         </a:rPr>
                         <a:t>Entender</a:t>
                       </a:r>
-                      <a:endParaRPr lang="en-US" sz="1000" dirty="0">
+                      <a:endParaRPr lang="en-US" sz="1100" dirty="0">
                         <a:latin typeface="Calibri" charset="0"/>
                         <a:ea typeface="Calibri" charset="0"/>
                         <a:cs typeface="Calibri" charset="0"/>
@@ -7816,7 +7503,7 @@
                         <a:buNone/>
                       </a:pPr>
                       <a:r>
-                        <a:rPr lang="en-US" sz="1000" dirty="0">
+                        <a:rPr lang="en-US" sz="1100" dirty="0">
                           <a:solidFill>
                             <a:srgbClr val="C2CFC7"/>
                           </a:solidFill>
@@ -7826,7 +7513,7 @@
                         </a:rPr>
                         <a:t>Deduzir dos requisitos se vale a pena</a:t>
                       </a:r>
-                      <a:endParaRPr lang="en-US" sz="1000" dirty="0">
+                      <a:endParaRPr lang="en-US" sz="1100" dirty="0">
                         <a:latin typeface="Calibri" charset="0"/>
                         <a:ea typeface="Calibri" charset="0"/>
                         <a:cs typeface="Calibri" charset="0"/>
@@ -7884,7 +7571,7 @@
                         <a:buNone/>
                       </a:pPr>
                       <a:r>
-                        <a:rPr lang="en-US" sz="1000" dirty="0">
+                        <a:rPr lang="en-US" sz="1100" dirty="0">
                           <a:solidFill>
                             <a:srgbClr val="EEF3EF"/>
                           </a:solidFill>
@@ -7894,7 +7581,7 @@
                         </a:rPr>
                         <a:t>Nota de 0 a 100 com o que atende e o que falta</a:t>
                       </a:r>
-                      <a:endParaRPr lang="en-US" sz="1000" dirty="0">
+                      <a:endParaRPr lang="en-US" sz="1100" dirty="0">
                         <a:latin typeface="Calibri" charset="0"/>
                         <a:ea typeface="Calibri" charset="0"/>
                         <a:cs typeface="Calibri" charset="0"/>
@@ -7954,7 +7641,7 @@
                         <a:buNone/>
                       </a:pPr>
                       <a:r>
-                        <a:rPr lang="en-US" sz="1000" b="1" dirty="0">
+                        <a:rPr lang="en-US" sz="1100" b="1" dirty="0">
                           <a:solidFill>
                             <a:srgbClr val="EEF3EF"/>
                           </a:solidFill>
@@ -7964,7 +7651,7 @@
                         </a:rPr>
                         <a:t>Repetir</a:t>
                       </a:r>
-                      <a:endParaRPr lang="en-US" sz="1000" dirty="0">
+                      <a:endParaRPr lang="en-US" sz="1100" dirty="0">
                         <a:latin typeface="Calibri" charset="0"/>
                         <a:ea typeface="Calibri" charset="0"/>
                         <a:cs typeface="Calibri" charset="0"/>
@@ -8022,7 +7709,7 @@
                         <a:buNone/>
                       </a:pPr>
                       <a:r>
-                        <a:rPr lang="en-US" sz="1000" dirty="0">
+                        <a:rPr lang="en-US" sz="1100" dirty="0">
                           <a:solidFill>
                             <a:srgbClr val="C2CFC7"/>
                           </a:solidFill>
@@ -8032,7 +7719,7 @@
                         </a:rPr>
                         <a:t>Reencontrar a mesma vaga republicada</a:t>
                       </a:r>
-                      <a:endParaRPr lang="en-US" sz="1000" dirty="0">
+                      <a:endParaRPr lang="en-US" sz="1100" dirty="0">
                         <a:latin typeface="Calibri" charset="0"/>
                         <a:ea typeface="Calibri" charset="0"/>
                         <a:cs typeface="Calibri" charset="0"/>
@@ -8090,7 +7777,7 @@
                         <a:buNone/>
                       </a:pPr>
                       <a:r>
-                        <a:rPr lang="en-US" sz="1000" dirty="0">
+                        <a:rPr lang="en-US" sz="1100" dirty="0">
                           <a:solidFill>
                             <a:srgbClr val="EEF3EF"/>
                           </a:solidFill>
@@ -8100,7 +7787,7 @@
                         </a:rPr>
                         <a:t>Deduplicação e histórico por pessoa</a:t>
                       </a:r>
-                      <a:endParaRPr lang="en-US" sz="1000" dirty="0">
+                      <a:endParaRPr lang="en-US" sz="1100" dirty="0">
                         <a:latin typeface="Calibri" charset="0"/>
                         <a:ea typeface="Calibri" charset="0"/>
                         <a:cs typeface="Calibri" charset="0"/>
@@ -8162,7 +7849,7 @@
         </p:nvSpPr>
         <p:spPr>
           <a:xfrm>
-            <a:off x="548640" y="3675888"/>
+            <a:off x="548640" y="3639312"/>
             <a:ext cx="8046720" cy="932688"/>
           </a:xfrm>
           <a:prstGeom prst="roundRect">
@@ -8189,7 +7876,7 @@
         </p:nvSpPr>
         <p:spPr>
           <a:xfrm>
-            <a:off x="3230880" y="3675888"/>
+            <a:off x="3230880" y="3639312"/>
             <a:ext cx="0" cy="932688"/>
           </a:xfrm>
           <a:prstGeom prst="line">
@@ -8212,7 +7899,7 @@
         </p:nvSpPr>
         <p:spPr>
           <a:xfrm>
-            <a:off x="5913120" y="3675888"/>
+            <a:off x="5913120" y="3639312"/>
             <a:ext cx="0" cy="932688"/>
           </a:xfrm>
           <a:prstGeom prst="line">
@@ -8235,7 +7922,7 @@
         </p:nvSpPr>
         <p:spPr>
           <a:xfrm>
-            <a:off x="731520" y="3840480"/>
+            <a:off x="731520" y="3803904"/>
             <a:ext cx="2316480" cy="274320"/>
           </a:xfrm>
           <a:prstGeom prst="rect">
@@ -8277,7 +7964,7 @@
         </p:nvSpPr>
         <p:spPr>
           <a:xfrm>
-            <a:off x="731520" y="4133088"/>
+            <a:off x="731520" y="4096512"/>
             <a:ext cx="2316480" cy="365760"/>
           </a:xfrm>
           <a:prstGeom prst="rect">
@@ -8297,7 +7984,7 @@
               <a:buNone/>
             </a:pPr>
             <a:r>
-              <a:rPr lang="en-US" sz="1000" dirty="0">
+              <a:rPr lang="en-US" sz="1100" dirty="0">
                 <a:solidFill>
                   <a:srgbClr val="C2CFC7"/>
                 </a:solidFill>
@@ -8307,7 +7994,7 @@
               </a:rPr>
               <a:t>do cadastro à primeira lista, mediana observada</a:t>
             </a:r>
-            <a:endParaRPr lang="en-US" sz="1000" dirty="0"/>
+            <a:endParaRPr lang="en-US" sz="1100" dirty="0"/>
           </a:p>
         </p:txBody>
       </p:sp>
@@ -8319,7 +8006,7 @@
         </p:nvSpPr>
         <p:spPr>
           <a:xfrm>
-            <a:off x="3413760" y="3840480"/>
+            <a:off x="3413760" y="3803904"/>
             <a:ext cx="2316480" cy="274320"/>
           </a:xfrm>
           <a:prstGeom prst="rect">
@@ -8361,7 +8048,7 @@
         </p:nvSpPr>
         <p:spPr>
           <a:xfrm>
-            <a:off x="3413760" y="4133088"/>
+            <a:off x="3413760" y="4096512"/>
             <a:ext cx="2316480" cy="365760"/>
           </a:xfrm>
           <a:prstGeom prst="rect">
@@ -8381,7 +8068,7 @@
               <a:buNone/>
             </a:pPr>
             <a:r>
-              <a:rPr lang="en-US" sz="1000" dirty="0">
+              <a:rPr lang="en-US" sz="1100" dirty="0">
                 <a:solidFill>
                   <a:srgbClr val="C2CFC7"/>
                 </a:solidFill>
@@ -8391,7 +8078,7 @@
               </a:rPr>
               <a:t>custo de um usuário novo: a extração é por vaga</a:t>
             </a:r>
-            <a:endParaRPr lang="en-US" sz="1000" dirty="0"/>
+            <a:endParaRPr lang="en-US" sz="1100" dirty="0"/>
           </a:p>
         </p:txBody>
       </p:sp>
@@ -8403,7 +8090,7 @@
         </p:nvSpPr>
         <p:spPr>
           <a:xfrm>
-            <a:off x="6096000" y="3840480"/>
+            <a:off x="6096000" y="3803904"/>
             <a:ext cx="2316480" cy="274320"/>
           </a:xfrm>
           <a:prstGeom prst="rect">
@@ -8445,7 +8132,7 @@
         </p:nvSpPr>
         <p:spPr>
           <a:xfrm>
-            <a:off x="6096000" y="4133088"/>
+            <a:off x="6096000" y="4096512"/>
             <a:ext cx="2316480" cy="365760"/>
           </a:xfrm>
           <a:prstGeom prst="rect">
@@ -8465,7 +8152,7 @@
               <a:buNone/>
             </a:pPr>
             <a:r>
-              <a:rPr lang="en-US" sz="1000" dirty="0">
+              <a:rPr lang="en-US" sz="1100" dirty="0">
                 <a:solidFill>
                   <a:srgbClr val="C2CFC7"/>
                 </a:solidFill>
@@ -8475,7 +8162,7 @@
               </a:rPr>
               <a:t>reconhecidos pelo catálogo, não só computação</a:t>
             </a:r>
-            <a:endParaRPr lang="en-US" sz="1000" dirty="0"/>
+            <a:endParaRPr lang="en-US" sz="1100" dirty="0"/>
           </a:p>
         </p:txBody>
       </p:sp>
@@ -8594,13 +8281,55 @@
       </p:sp>
       <p:sp>
         <p:nvSpPr>
-          <p:cNvPr id="4" name="Shape 2"/>
+          <p:cNvPr id="4" name="Text 2"/>
+          <p:cNvSpPr txBox="1"/>
+          <p:nvPr/>
+        </p:nvSpPr>
+        <p:spPr>
+          <a:xfrm>
+            <a:off x="548640" y="1170432"/>
+            <a:ext cx="8046720" cy="566928"/>
+          </a:xfrm>
+          <a:prstGeom prst="rect">
+            <a:avLst/>
+          </a:prstGeom>
+          <a:noFill/>
+          <a:ln/>
+        </p:spPr>
+        <p:txBody>
+          <a:bodyPr wrap="square" lIns="0" tIns="0" rIns="0" bIns="0" rtlCol="0" anchor="ctr"/>
+          <a:lstStyle/>
+          <a:p>
+            <a:pPr indent="0" marL="0">
+              <a:lnSpc>
+                <a:spcPct val="110000"/>
+              </a:lnSpc>
+              <a:buNone/>
+            </a:pPr>
+            <a:r>
+              <a:rPr lang="en-US" sz="1300" dirty="0">
+                <a:solidFill>
+                  <a:srgbClr val="C2CFC7"/>
+                </a:solidFill>
+                <a:latin typeface="Calibri" pitchFamily="34" charset="0"/>
+                <a:ea typeface="Calibri" pitchFamily="34" charset="-122"/>
+                <a:cs typeface="Calibri" pitchFamily="34" charset="-120"/>
+              </a:rPr>
+              <a:t>O sistema entrega todo dia sem intervenção. O que ainda não existe é evidência de que a recomendação serve para quem recebe.</a:t>
+            </a:r>
+            <a:endParaRPr lang="en-US" sz="1300" dirty="0"/>
+          </a:p>
+        </p:txBody>
+      </p:sp>
+      <p:sp>
+        <p:nvSpPr>
+          <p:cNvPr id="5" name="Shape 3"/>
           <p:cNvSpPr/>
           <p:nvPr/>
         </p:nvSpPr>
         <p:spPr>
           <a:xfrm>
-            <a:off x="548640" y="1481328"/>
+            <a:off x="548640" y="1792224"/>
             <a:ext cx="3931920" cy="2377440"/>
           </a:xfrm>
           <a:prstGeom prst="roundRect">
@@ -8621,13 +8350,13 @@
       </p:sp>
       <p:sp>
         <p:nvSpPr>
-          <p:cNvPr id="5" name="Text 3"/>
-          <p:cNvSpPr txBox="1"/>
-          <p:nvPr/>
-        </p:nvSpPr>
-        <p:spPr>
-          <a:xfrm>
-            <a:off x="731520" y="1627632"/>
+          <p:cNvPr id="6" name="Text 4"/>
+          <p:cNvSpPr txBox="1"/>
+          <p:nvPr/>
+        </p:nvSpPr>
+        <p:spPr>
+          <a:xfrm>
+            <a:off x="731520" y="1938528"/>
             <a:ext cx="3566160" cy="384048"/>
           </a:xfrm>
           <a:prstGeom prst="rect">
@@ -8647,7 +8376,7 @@
               <a:buNone/>
             </a:pPr>
             <a:r>
-              <a:rPr lang="en-US" sz="1250" b="1" dirty="0">
+              <a:rPr lang="en-US" sz="1350" b="1" dirty="0">
                 <a:solidFill>
                   <a:srgbClr val="EEF3EF"/>
                 </a:solidFill>
@@ -8657,19 +8386,19 @@
               </a:rPr>
               <a:t>Riscos e limitações</a:t>
             </a:r>
-            <a:endParaRPr lang="en-US" sz="1250" dirty="0"/>
-          </a:p>
-        </p:txBody>
-      </p:sp>
-      <p:sp>
-        <p:nvSpPr>
-          <p:cNvPr id="6" name="Text 4"/>
-          <p:cNvSpPr txBox="1"/>
-          <p:nvPr/>
-        </p:nvSpPr>
-        <p:spPr>
-          <a:xfrm>
-            <a:off x="731520" y="2029968"/>
+            <a:endParaRPr lang="en-US" sz="1350" dirty="0"/>
+          </a:p>
+        </p:txBody>
+      </p:sp>
+      <p:sp>
+        <p:nvSpPr>
+          <p:cNvPr id="7" name="Text 5"/>
+          <p:cNvSpPr txBox="1"/>
+          <p:nvPr/>
+        </p:nvSpPr>
+        <p:spPr>
+          <a:xfrm>
+            <a:off x="731520" y="2340864"/>
             <a:ext cx="3566160" cy="1682496"/>
           </a:xfrm>
           <a:prstGeom prst="rect">
@@ -8693,7 +8422,7 @@
               <a:buChar char="•"/>
             </a:pPr>
             <a:r>
-              <a:rPr lang="en-US" sz="1050" dirty="0">
+              <a:rPr lang="en-US" sz="1150" dirty="0">
                 <a:solidFill>
                   <a:srgbClr val="C2CFC7"/>
                 </a:solidFill>
@@ -8703,7 +8432,7 @@
               </a:rPr>
               <a:t>Zero vaga marcada como útil em 410 entregas: 12 aberturas e 6 respostas</a:t>
             </a:r>
-            <a:endParaRPr lang="en-US" sz="1050" dirty="0"/>
+            <a:endParaRPr lang="en-US" sz="1150" dirty="0"/>
           </a:p>
           <a:p>
             <a:pPr marL="342900" indent="-342900">
@@ -8717,7 +8446,7 @@
               <a:buChar char="•"/>
             </a:pPr>
             <a:r>
-              <a:rPr lang="en-US" sz="1050" dirty="0">
+              <a:rPr lang="en-US" sz="1150" dirty="0">
                 <a:solidFill>
                   <a:srgbClr val="C2CFC7"/>
                 </a:solidFill>
@@ -8727,7 +8456,7 @@
               </a:rPr>
               <a:t>Uma fonte só: a Adzuna responde por tudo, e a Gupy saiu pelos termos de uso</a:t>
             </a:r>
-            <a:endParaRPr lang="en-US" sz="1050" dirty="0"/>
+            <a:endParaRPr lang="en-US" sz="1150" dirty="0"/>
           </a:p>
           <a:p>
             <a:pPr marL="342900" indent="-342900">
@@ -8741,7 +8470,7 @@
               <a:buChar char="•"/>
             </a:pPr>
             <a:r>
-              <a:rPr lang="en-US" sz="1050" dirty="0">
+              <a:rPr lang="en-US" sz="1150" dirty="0">
                 <a:solidFill>
                   <a:srgbClr val="C2CFC7"/>
                 </a:solidFill>
@@ -8751,19 +8480,19 @@
               </a:rPr>
               <a:t>O estudante é um pagador improvável: os concorrentes são gratuitos para ele</a:t>
             </a:r>
-            <a:endParaRPr lang="en-US" sz="1050" dirty="0"/>
-          </a:p>
-        </p:txBody>
-      </p:sp>
-      <p:sp>
-        <p:nvSpPr>
-          <p:cNvPr id="7" name="Shape 5"/>
+            <a:endParaRPr lang="en-US" sz="1150" dirty="0"/>
+          </a:p>
+        </p:txBody>
+      </p:sp>
+      <p:sp>
+        <p:nvSpPr>
+          <p:cNvPr id="8" name="Shape 6"/>
           <p:cNvSpPr/>
           <p:nvPr/>
         </p:nvSpPr>
         <p:spPr>
           <a:xfrm>
-            <a:off x="4663440" y="1481328"/>
+            <a:off x="4663440" y="1792224"/>
             <a:ext cx="3931920" cy="2377440"/>
           </a:xfrm>
           <a:prstGeom prst="roundRect">
@@ -8784,13 +8513,13 @@
       </p:sp>
       <p:sp>
         <p:nvSpPr>
-          <p:cNvPr id="8" name="Text 6"/>
-          <p:cNvSpPr txBox="1"/>
-          <p:nvPr/>
-        </p:nvSpPr>
-        <p:spPr>
-          <a:xfrm>
-            <a:off x="4846320" y="1627632"/>
+          <p:cNvPr id="9" name="Text 7"/>
+          <p:cNvSpPr txBox="1"/>
+          <p:nvPr/>
+        </p:nvSpPr>
+        <p:spPr>
+          <a:xfrm>
+            <a:off x="4846320" y="1938528"/>
             <a:ext cx="3566160" cy="384048"/>
           </a:xfrm>
           <a:prstGeom prst="rect">
@@ -8810,7 +8539,7 @@
               <a:buNone/>
             </a:pPr>
             <a:r>
-              <a:rPr lang="en-US" sz="1250" b="1" dirty="0">
+              <a:rPr lang="en-US" sz="1350" b="1" dirty="0">
                 <a:solidFill>
                   <a:srgbClr val="EEF3EF"/>
                 </a:solidFill>
@@ -8820,19 +8549,19 @@
               </a:rPr>
               <a:t>Dados e privacidade</a:t>
             </a:r>
-            <a:endParaRPr lang="en-US" sz="1250" dirty="0"/>
-          </a:p>
-        </p:txBody>
-      </p:sp>
-      <p:sp>
-        <p:nvSpPr>
-          <p:cNvPr id="9" name="Text 7"/>
-          <p:cNvSpPr txBox="1"/>
-          <p:nvPr/>
-        </p:nvSpPr>
-        <p:spPr>
-          <a:xfrm>
-            <a:off x="4846320" y="2029968"/>
+            <a:endParaRPr lang="en-US" sz="1350" dirty="0"/>
+          </a:p>
+        </p:txBody>
+      </p:sp>
+      <p:sp>
+        <p:nvSpPr>
+          <p:cNvPr id="10" name="Text 8"/>
+          <p:cNvSpPr txBox="1"/>
+          <p:nvPr/>
+        </p:nvSpPr>
+        <p:spPr>
+          <a:xfrm>
+            <a:off x="4846320" y="2340864"/>
             <a:ext cx="3566160" cy="1682496"/>
           </a:xfrm>
           <a:prstGeom prst="rect">
@@ -8856,7 +8585,7 @@
               <a:buChar char="•"/>
             </a:pPr>
             <a:r>
-              <a:rPr lang="en-US" sz="1050" dirty="0">
+              <a:rPr lang="en-US" sz="1150" dirty="0">
                 <a:solidFill>
                   <a:srgbClr val="C2CFC7"/>
                 </a:solidFill>
@@ -8866,7 +8595,7 @@
               </a:rPr>
               <a:t>Origem: API oficial da Adzuna, com atribuição obrigatória em cada anúncio</a:t>
             </a:r>
-            <a:endParaRPr lang="en-US" sz="1050" dirty="0"/>
+            <a:endParaRPr lang="en-US" sz="1150" dirty="0"/>
           </a:p>
           <a:p>
             <a:pPr marL="342900" indent="-342900">
@@ -8880,7 +8609,7 @@
               <a:buChar char="•"/>
             </a:pPr>
             <a:r>
-              <a:rPr lang="en-US" sz="1050" dirty="0">
+              <a:rPr lang="en-US" sz="1150" dirty="0">
                 <a:solidFill>
                   <a:srgbClr val="C2CFC7"/>
                 </a:solidFill>
@@ -8890,7 +8619,7 @@
               </a:rPr>
               <a:t>Formato: JSON das vagas e JSON validado por schema na saída da IA</a:t>
             </a:r>
-            <a:endParaRPr lang="en-US" sz="1050" dirty="0"/>
+            <a:endParaRPr lang="en-US" sz="1150" dirty="0"/>
           </a:p>
           <a:p>
             <a:pPr marL="342900" indent="-342900">
@@ -8904,7 +8633,7 @@
               <a:buChar char="•"/>
             </a:pPr>
             <a:r>
-              <a:rPr lang="en-US" sz="1050" dirty="0">
+              <a:rPr lang="en-US" sz="1150" dirty="0">
                 <a:solidFill>
                   <a:srgbClr val="C2CFC7"/>
                 </a:solidFill>
@@ -8914,7 +8643,7 @@
               </a:rPr>
               <a:t>O perfil nunca vai para a IA: o prompt só contém o anúncio</a:t>
             </a:r>
-            <a:endParaRPr lang="en-US" sz="1050" dirty="0"/>
+            <a:endParaRPr lang="en-US" sz="1150" dirty="0"/>
           </a:p>
         </p:txBody>
       </p:sp>

</xml_diff>